<commit_message>
presentation: add speaker notes, SPEAKER_NOTES.md, and Prompt Engineering chip
- Full per-slide talking script embedded in the deck (PowerPoint Presenter View)
- docs copy at finetune-quantization/presentation/SPEAKER_NOTES.md
- Title slide: add "Prompt Engineering" to the component chip row

Co-Authored-By: Claude Opus 4.8 <noreply@anthropic.com>
</commit_message>
<xml_diff>
--- a/finetune-quantization/presentation/ParentWise_Platform.pptx
+++ b/finetune-quantization/presentation/ParentWise_Platform.pptx
@@ -519,7 +519,7 @@
           <a:p>
             <a:r>
               <a:rPr lang="en-US" dirty="0"/>
-              <a:t>ParentWise: an Arabic-first parenting assistant combining RAG, a fine-tuned Nile-Chat-4B model, and voice I/O. We tune behaviour and ground facts.</a:t>
+              <a:t>This is ParentWise — an Arabic-first parenting assistant. A parent asks a question, by voice or text, in Egyptian colloquial Arabic, and gets a warm, evidence-grounded answer that knows when to step back and send them to a professional. It brings together three Gen-AI pieces — retrieval, a fine-tuned model, and voice — and our one-line philosophy is: we tune the model's behaviour, and we ground its facts.</a:t>
             </a:r>
             <a:endParaRPr lang="en-US" dirty="0"/>
           </a:p>
@@ -607,7 +607,7 @@
           <a:p>
             <a:r>
               <a:rPr lang="en-US" dirty="0"/>
-              <a:t>The prompting strategy is a three-stage defense-in-depth pipeline: a zero-shot router, a role/few-shot/CoT generator, and an independent chain-of-verification pass.</a:t>
+              <a:t>On the prompt-engineering side, safety is defense-in-depth — the fine-tuned model isn't the only line of defense. First a Router classifies intent with zero-shot, and skips retrieval and generation entirely for medical or out-of-scope questions. Then the Generator uses role, few-shot, and a silent chain-of-thought. Finally an independent Verifier — a separate call, not the model grading itself — checks grounding and safety before anything ships. Three independent checks, each catching what the others miss.</a:t>
             </a:r>
             <a:endParaRPr lang="en-US" dirty="0"/>
           </a:p>
@@ -695,7 +695,7 @@
           <a:p>
             <a:r>
               <a:rPr lang="en-US" dirty="0"/>
-              <a:t>Six prompt-engineering techniques: role prompting, zero-shot classification, few-shot, chain-of-thought, retrieval-grounding, and chain-of-verification.</a:t>
+              <a:t>Zooming in, we use six named prompt-engineering techniques, each doing one job — not stacked for show. Role prompting sets the persona; zero-shot classification drives the router; few-shot examples demonstrate the response shape; chain-of-thought does silent safety and age-fit reasoning; retrieval-grounding restricts answers to the sources; and chain-of-verification double-checks the draft. Together they're the glue between RAG and the fine-tuned model.</a:t>
             </a:r>
             <a:endParaRPr lang="en-US" dirty="0"/>
           </a:p>
@@ -783,7 +783,7 @@
           <a:p>
             <a:r>
               <a:rPr lang="en-US" dirty="0"/>
-              <a:t>Four reliability safeguards: age-awareness, evidence vs opinion, medical redirection, and admitting insufficient context.</a:t>
+              <a:t>These are the answer-quality guarantees users actually feel. Answers are age-aware, tailored to the child's age. We distinguish evidence from opinion. Medical questions are redirected to a professional. And when the retrieved context isn't enough, the model says so out loud instead of making something up. Safety here isn't a prompt line — it's enforced before generation.</a:t>
             </a:r>
             <a:endParaRPr lang="en-US" dirty="0"/>
           </a:p>
@@ -871,7 +871,7 @@
           <a:p>
             <a:r>
               <a:rPr lang="en-US" dirty="0"/>
-              <a:t>Testing surfaced and fixed real bugs: router misclassification (fixed with few-shot) and irrelevant keyword retrieval (fixed with stopword filtering + overlap threshold).</a:t>
+              <a:t>Every fix on this slide came from testing against the real model and real UNICEF data, not assumptions. We validated 5 test categories and found and fixed 3 real bugs. The router first misfired — a ball-sharing question was tagged medical — until we added five few-shot examples. And keyword retrieval pulled irrelevant chunks until we added stopword filtering and an overlap threshold, so now it falls back honestly instead of hallucinating. At the bottom you can see routing working: behavioural gets a grounded answer, medical a clean redirect, out-of-scope is politely declined.</a:t>
             </a:r>
             <a:endParaRPr lang="en-US" dirty="0"/>
           </a:p>
@@ -959,7 +959,7 @@
           <a:p>
             <a:r>
               <a:rPr lang="en-US" dirty="0"/>
-              <a:t>The React frontend: RTL-first Egyptian-Arabic chat UI with MediaRecorder voice capture and a clean mock-to-real swap point for backend wiring.</a:t>
+              <a:t>The frontend is a working React chat UI, built right-to-left first — because that's the actual language of the product, down to the sidebar, message alignment and every string. Voice recording uses the browser's MediaRecorder with a live 'listening' state, ready for the STT endpoint. And there's a clean mock-to-real swap point: two isolated functions for chat and transcription, so wiring the real backend touches no UI code.</a:t>
             </a:r>
             <a:endParaRPr lang="en-US" dirty="0"/>
           </a:p>
@@ -1047,7 +1047,7 @@
           <a:p>
             <a:r>
               <a:rPr lang="en-US" dirty="0"/>
-              <a:t>Voice component: faster-whisper STT (VAD-tuned) and NAMAA Egyptian TTS, delivered as a FastAPI service that calls the RAG API.</a:t>
+              <a:t>Component three is voice, and it's hands-free by design — parents can ask while their hands are full. Speech-to-text uses faster-whisper, forced to Arabic, with the voice-activity threshold tuned to 1500 milliseconds after testing showed shorter pauses were cutting sentences off. Text-to-speech uses the NAMAA Egyptian voice. It's a standalone FastAPI service wired end-to-end into the RAG and fine-tuned model over HTTP.</a:t>
             </a:r>
             <a:endParaRPr lang="en-US" dirty="0"/>
           </a:p>
@@ -1135,7 +1135,7 @@
           <a:p>
             <a:r>
               <a:rPr lang="en-US" dirty="0"/>
-              <a:t>The headline result: a fully functional voice-to-voice pipeline, demoed live end-to-end.</a:t>
+              <a:t>Put it together and this is the headline result: a full voice-to-voice pipeline. The parent speaks; STT transcribes; RAG plus the fine-tuned Nile-Chat-4B produces a grounded answer; and TTS speaks it back in Egyptian Arabic. This isn't a mock-up — we tested it live, end-to-end.</a:t>
             </a:r>
             <a:endParaRPr lang="en-US" dirty="0"/>
           </a:p>
@@ -1223,7 +1223,7 @@
           <a:p>
             <a:r>
               <a:rPr lang="en-US" dirty="0"/>
-              <a:t>Honest evaluation: strong tone and most refusals, but real safety misses (dosage, choking) to fix.</a:t>
+              <a:t>Now an honest read of the evaluation — 28 rubric-graded held-out questions, where safety-critical items are hard fails, about 67% overall. What worked: warm on-persona tone, correct refusals on several dangerous myths, emergencies routed to a doctor, and it runs on CPU. What we still need to fix is real: a dosage question produced a number, a choking case wasn't escalated, some facts were off, and a few out-of-scope questions got answered. We show the failures, we don't hide them.</a:t>
             </a:r>
             <a:endParaRPr lang="en-US" dirty="0"/>
           </a:p>
@@ -1311,7 +1311,7 @@
           <a:p>
             <a:r>
               <a:rPr lang="en-US" dirty="0"/>
-              <a:t>Limitations (not medical advice, imperfect refusals, narrow scope, STT/TTS caveats) and the future roadmap: expand, strengthen, ground, broaden, upgrade.</a:t>
+              <a:t>To close, the honest limitations. This is not a substitute for professional advice; the safety refusals aren't perfect yet; facts are only as good as the sources; coverage is deliberately narrow; and STT can drift toward formal Arabic while TTS leans on a hosted service. Our roadmap follows directly: expand the safety data, strengthen refusal training, ground all facts through RAG, broaden topics and ages, and upgrade to a dialect-specific STT and a private TTS. A clean, working small system beats an overextended one. Thank you — happy to take questions.</a:t>
             </a:r>
             <a:endParaRPr lang="en-US" dirty="0"/>
           </a:p>
@@ -1399,7 +1399,7 @@
           <a:p>
             <a:r>
               <a:rPr lang="en-US" dirty="0"/>
-              <a:t>Problem, audience, and the two design commitments: teach behaviour / ground facts, and a hard medical-safety boundary enforced twice.</a:t>
+              <a:t>The problem: parents face everyday challenges — tantrums, discipline, screen time, sleep — and today they get scattered, inconsistent advice from social media. Our users are parents of 0-to-12-year-olds, especially first-timers. Two commitments drive the whole design. First, teach behaviour and ground facts: fine-tuning shapes how it answers, RAG decides what it answers with. Second, a hard safety boundary — anything medical or an emergency is refused and redirected, and that's enforced twice.</a:t>
             </a:r>
             <a:endParaRPr lang="en-US" dirty="0"/>
           </a:p>
@@ -1487,7 +1487,7 @@
           <a:p>
             <a:r>
               <a:rPr lang="en-US" dirty="0"/>
-              <a:t>End-to-end flow: React frontend to FastAPI backend, which runs STT (if voice), builds the prompt with retrieved ChromaDB context, calls the fine-tuned QLoRA model, returns text, and stores per-session history.</a:t>
+              <a:t>Here's how a question flows. The user speaks or types into the React frontend, which calls the FastAPI backend. Inside the backend: if it's voice, Whisper transcribes it; we build a prompt from the system prompt, few-shot examples and retrieved context; the RAG retriever pulls the top chunks from ChromaDB; and the fine-tuned QLoRA model produces the answer. That text goes back to the frontend, and every exchange is stored per session in Postgres or SQLite.</a:t>
             </a:r>
             <a:endParaRPr lang="en-US" dirty="0"/>
           </a:p>
@@ -1575,7 +1575,7 @@
           <a:p>
             <a:r>
               <a:rPr lang="en-US" dirty="0"/>
-              <a:t>Knowledge base: 944 chunks from 34 documents (11 PDFs, 13 web, 10 research), built with structure-aware chunking and Arabic NFKC normalization.</a:t>
+              <a:t>Component one is retrieval. Our knowledge base is 944 chunks drawn from 34 real documents — 11 PDFs, 13 web sources, and 10 research papers — all from UNICEF, WHO and academic parenting research. We built it with structure-aware chunking, so we never return an orphaned sentence, and Arabic Unicode normalization so retrieval works reliably on Arabic. The point: we retrieve real evidence, not hallucinated advice.</a:t>
             </a:r>
             <a:endParaRPr lang="en-US" dirty="0"/>
           </a:p>
@@ -1663,7 +1663,7 @@
           <a:p>
             <a:r>
               <a:rPr lang="en-US" dirty="0"/>
-              <a:t>Retrieval engine: BGE-M3 dense (1024-dim) + BM25 sparse, fused with RRF, metadata-ranked, and reranked to the final 8 chunks (min confidence 0.1).</a:t>
+              <a:t>Retrieval is hybrid, because neither method alone is enough. Dense BGE-M3 embeddings catch meaning even when the wording differs; BM25 catches exact Arabic terms that embeddings can dilute. We fuse the two with Reciprocal Rank Fusion — no hand-tuned weights — then apply metadata ranking and a cross-encoder reranker, landing on the 8 best chunks for the model. Two retrievers see what one alone would miss.</a:t>
             </a:r>
             <a:endParaRPr lang="en-US" dirty="0"/>
           </a:p>
@@ -1751,7 +1751,7 @@
           <a:p>
             <a:r>
               <a:rPr lang="en-US" dirty="0"/>
-              <a:t>Deterministic safety gate: 7 risk categories, 4 hard-blocked (child abuse, violence, self-harm, emergency) to crisis resources, and soft boundaries (medical, mental health) answered with a professional nudge, never a diagnosis.</a:t>
+              <a:t>Safety is handled before generation, not after. A deterministic gate classifies every query across 7 risk categories. Four are hard-blocked — child abuse, violence, self-harm, and emergencies — and go straight to a safety response with crisis resources, with zero retrieval calls. Medical and mental-health are soft boundaries: we give general information and nudge toward a professional, never a diagnosis. A dangerous question never reaches the model.</a:t>
             </a:r>
             <a:endParaRPr lang="en-US" dirty="0"/>
           </a:p>
@@ -1839,7 +1839,7 @@
           <a:p>
             <a:r>
               <a:rPr lang="en-US" dirty="0"/>
-              <a:t>A structured context-injection template, built on the exact base system message the model was tuned against.</a:t>
+              <a:t>This is the bridge between retrieval and the model. Step one, we formulate the retrieval query; step two, we inject the retrieved chunks into a structured, per-source template; step three, the model generates grounded — using only those sources, and citing them. Crucially, the system prompt starts from the exact base message the model was fine-tuned on, so the RAG rules build on the training instead of fighting it.</a:t>
             </a:r>
             <a:endParaRPr lang="en-US" dirty="0"/>
           </a:p>
@@ -1927,7 +1927,7 @@
           <a:p>
             <a:r>
               <a:rPr lang="en-US" dirty="0"/>
-              <a:t>QLoRA config and the 507-pair semi-synthetic dataset (483 grounded + 24 safety), split 482/25 with a 28-item held-out test.</a:t>
+              <a:t>Component two is fine-tuning. We adapted Nile-Chat-4B with QLoRA: the base model is frozen in 4-bit, and we train lightweight adapters — under one percent of the parameters — with rank 16, learning rate 1e-4, for 2 epochs. The dataset is 507 Q&amp;A pairs: 483 grounded parenting pairs plus 24 safety and refusal pairs, split into 482 train, 25 validation, and a 28-item held-out test with zero overlap. We fine-tune for tone and safety, not facts.</a:t>
             </a:r>
             <a:endParaRPr lang="en-US" dirty="0"/>
           </a:p>
@@ -2015,7 +2015,7 @@
           <a:p>
             <a:r>
               <a:rPr lang="en-US" dirty="0"/>
-              <a:t>Quantization to GGUF Q4_K_M: ~8GB to 2.5GB, ~9.2 tok/s on CPU, no GPU needed to serve.</a:t>
+              <a:t>Then we optimize for deployment. Post-training quantization to GGUF Q4_K_M takes the model from about 8 gigabytes down to 2.5 — roughly three times smaller — and it runs on a laptop CPU at about 9 tokens per second, with no GPU required to serve. Same behaviour, a third of the size, so it runs right next to the RAG stack, anywhere.</a:t>
             </a:r>
             <a:endParaRPr lang="en-US" dirty="0"/>
           </a:p>
@@ -2563,7 +2563,7 @@
         <p:spPr>
           <a:xfrm>
             <a:off x="822960" y="5029200"/>
-            <a:ext cx="818388" cy="475488"/>
+            <a:ext cx="804672" cy="475488"/>
           </a:xfrm>
           <a:prstGeom prst="roundRect">
             <a:avLst>
@@ -2592,7 +2592,7 @@
         <p:spPr>
           <a:xfrm>
             <a:off x="822960" y="5029200"/>
-            <a:ext cx="818388" cy="475488"/>
+            <a:ext cx="804672" cy="475488"/>
           </a:xfrm>
           <a:prstGeom prst="rect">
             <a:avLst/>
@@ -2630,8 +2630,8 @@
         </p:nvSpPr>
         <p:spPr>
           <a:xfrm>
-            <a:off x="1897380" y="5029200"/>
-            <a:ext cx="3236976" cy="475488"/>
+            <a:off x="1883664" y="5029200"/>
+            <a:ext cx="3118104" cy="475488"/>
           </a:xfrm>
           <a:prstGeom prst="roundRect">
             <a:avLst>
@@ -2659,8 +2659,8 @@
         </p:nvSpPr>
         <p:spPr>
           <a:xfrm>
-            <a:off x="1897380" y="5029200"/>
-            <a:ext cx="3236976" cy="475488"/>
+            <a:off x="1883664" y="5029200"/>
+            <a:ext cx="3118104" cy="475488"/>
           </a:xfrm>
           <a:prstGeom prst="rect">
             <a:avLst/>
@@ -2698,8 +2698,8 @@
         </p:nvSpPr>
         <p:spPr>
           <a:xfrm>
-            <a:off x="5390388" y="5029200"/>
-            <a:ext cx="2290572" cy="475488"/>
+            <a:off x="5257800" y="5029200"/>
+            <a:ext cx="2313432" cy="475488"/>
           </a:xfrm>
           <a:prstGeom prst="roundRect">
             <a:avLst>
@@ -2727,8 +2727,8 @@
         </p:nvSpPr>
         <p:spPr>
           <a:xfrm>
-            <a:off x="5390388" y="5029200"/>
-            <a:ext cx="2290572" cy="475488"/>
+            <a:off x="5257800" y="5029200"/>
+            <a:ext cx="2313432" cy="475488"/>
           </a:xfrm>
           <a:prstGeom prst="rect">
             <a:avLst/>
@@ -2752,6 +2752,74 @@
                 <a:ea typeface="Calibri" pitchFamily="34" charset="-122"/>
                 <a:cs typeface="Calibri" pitchFamily="34" charset="-120"/>
               </a:rPr>
+              <a:t>Prompt Engineering</a:t>
+            </a:r>
+            <a:endParaRPr lang="en-US" sz="1250" dirty="0"/>
+          </a:p>
+        </p:txBody>
+      </p:sp>
+      <p:sp>
+        <p:nvSpPr>
+          <p:cNvPr id="12" name="Shape 10"/>
+          <p:cNvSpPr/>
+          <p:nvPr/>
+        </p:nvSpPr>
+        <p:spPr>
+          <a:xfrm>
+            <a:off x="7827264" y="5029200"/>
+            <a:ext cx="2212848" cy="475488"/>
+          </a:xfrm>
+          <a:prstGeom prst="roundRect">
+            <a:avLst>
+              <a:gd name="adj" fmla="val 50000"/>
+            </a:avLst>
+          </a:prstGeom>
+          <a:solidFill>
+            <a:srgbClr val="FFFFFF"/>
+          </a:solidFill>
+          <a:ln/>
+          <a:effectLst>
+            <a:outerShdw sx="100000" sy="100000" kx="0" ky="0" algn="bl" rotWithShape="0" blurRad="165100" dist="38100" dir="5400000">
+              <a:srgbClr val="B7A6C9">
+                <a:alpha val="26000"/>
+              </a:srgbClr>
+            </a:outerShdw>
+          </a:effectLst>
+        </p:spPr>
+      </p:sp>
+      <p:sp>
+        <p:nvSpPr>
+          <p:cNvPr id="13" name="Text 11"/>
+          <p:cNvSpPr txBox="1"/>
+          <p:nvPr/>
+        </p:nvSpPr>
+        <p:spPr>
+          <a:xfrm>
+            <a:off x="7827264" y="5029200"/>
+            <a:ext cx="2212848" cy="475488"/>
+          </a:xfrm>
+          <a:prstGeom prst="rect">
+            <a:avLst/>
+          </a:prstGeom>
+          <a:noFill/>
+          <a:ln/>
+        </p:spPr>
+        <p:txBody>
+          <a:bodyPr wrap="square" lIns="0" tIns="0" rIns="0" bIns="0" rtlCol="0" anchor="ctr"/>
+          <a:lstStyle/>
+          <a:p>
+            <a:pPr algn="ctr" indent="0" marL="0">
+              <a:buNone/>
+            </a:pPr>
+            <a:r>
+              <a:rPr lang="en-US" sz="1250" b="1" dirty="0">
+                <a:solidFill>
+                  <a:srgbClr val="C06A3C"/>
+                </a:solidFill>
+                <a:latin typeface="Calibri" pitchFamily="34" charset="0"/>
+                <a:ea typeface="Calibri" pitchFamily="34" charset="-122"/>
+                <a:cs typeface="Calibri" pitchFamily="34" charset="-120"/>
+              </a:rPr>
               <a:t>Voice · STT + TTS</a:t>
             </a:r>
             <a:endParaRPr lang="en-US" sz="1250" dirty="0"/>
@@ -2760,7 +2828,7 @@
       </p:sp>
       <p:sp>
         <p:nvSpPr>
-          <p:cNvPr id="12" name="Text 10"/>
+          <p:cNvPr id="14" name="Text 12"/>
           <p:cNvSpPr txBox="1"/>
           <p:nvPr/>
         </p:nvSpPr>

</xml_diff>

<commit_message>
presentation: fold in reference deck details
- Intro: add scope topics + "Requirements met" checklist band
- Fine-tuning: add dropout 0.05 as a fifth hyperparameter tile
- Findings: surface 67% / 8-12 / 9.2 tok/s as headline stat callouts

Co-Authored-By: Claude Opus 4.8 <noreply@anthropic.com>
</commit_message>
<xml_diff>
--- a/finetune-quantization/presentation/ParentWise_Platform.pptx
+++ b/finetune-quantization/presentation/ParentWise_Platform.pptx
@@ -9942,7 +9942,7 @@
                 <a:ea typeface="Calibri" pitchFamily="34" charset="-122"/>
                 <a:cs typeface="Calibri" pitchFamily="34" charset="-120"/>
               </a:rPr>
-              <a:t>28 rubric-graded held-out questions · safety-critical items are hard fails · ~67% overall.</a:t>
+              <a:t>28-question held-out test · rubric-graded on the quantized GGUF model (greedy).</a:t>
             </a:r>
             <a:endParaRPr lang="en-US" sz="1400" dirty="0"/>
           </a:p>
@@ -9956,12 +9956,12 @@
         </p:nvSpPr>
         <p:spPr>
           <a:xfrm>
-            <a:off x="640080" y="1965960"/>
-            <a:ext cx="5257800" cy="3566160"/>
+            <a:off x="640080" y="1810512"/>
+            <a:ext cx="3520440" cy="914400"/>
           </a:xfrm>
           <a:prstGeom prst="roundRect">
             <a:avLst>
-              <a:gd name="adj" fmla="val 2821"/>
+              <a:gd name="adj" fmla="val 11000"/>
             </a:avLst>
           </a:prstGeom>
           <a:solidFill>
@@ -9985,7 +9985,337 @@
         </p:nvSpPr>
         <p:spPr>
           <a:xfrm>
-            <a:off x="914400" y="2194560"/>
+            <a:off x="640080" y="1938528"/>
+            <a:ext cx="3520440" cy="457200"/>
+          </a:xfrm>
+          <a:prstGeom prst="rect">
+            <a:avLst/>
+          </a:prstGeom>
+          <a:noFill/>
+          <a:ln/>
+        </p:spPr>
+        <p:txBody>
+          <a:bodyPr wrap="square" lIns="0" tIns="0" rIns="0" bIns="0" rtlCol="0" anchor="ctr"/>
+          <a:lstStyle/>
+          <a:p>
+            <a:pPr algn="ctr" indent="0" marL="0">
+              <a:buNone/>
+            </a:pPr>
+            <a:r>
+              <a:rPr lang="en-US" sz="3000" b="1" dirty="0">
+                <a:solidFill>
+                  <a:srgbClr val="C06A3C"/>
+                </a:solidFill>
+                <a:latin typeface="Cambria" pitchFamily="34" charset="0"/>
+                <a:ea typeface="Cambria" pitchFamily="34" charset="-122"/>
+                <a:cs typeface="Cambria" pitchFamily="34" charset="-120"/>
+              </a:rPr>
+              <a:t>67%</a:t>
+            </a:r>
+            <a:endParaRPr lang="en-US" sz="3000" dirty="0"/>
+          </a:p>
+        </p:txBody>
+      </p:sp>
+      <p:sp>
+        <p:nvSpPr>
+          <p:cNvPr id="7" name="Text 5"/>
+          <p:cNvSpPr txBox="1"/>
+          <p:nvPr/>
+        </p:nvSpPr>
+        <p:spPr>
+          <a:xfrm>
+            <a:off x="749808" y="2322576"/>
+            <a:ext cx="3300984" cy="384048"/>
+          </a:xfrm>
+          <a:prstGeom prst="rect">
+            <a:avLst/>
+          </a:prstGeom>
+          <a:noFill/>
+          <a:ln/>
+        </p:spPr>
+        <p:txBody>
+          <a:bodyPr wrap="square" lIns="0" tIns="0" rIns="0" bIns="0" rtlCol="0" anchor="t"/>
+          <a:lstStyle/>
+          <a:p>
+            <a:pPr algn="ctr" indent="0" marL="0">
+              <a:lnSpc>
+                <a:spcPct val="100000"/>
+              </a:lnSpc>
+              <a:buNone/>
+            </a:pPr>
+            <a:r>
+              <a:rPr lang="en-US" sz="950" b="1" spc="120" kern="0" dirty="0">
+                <a:solidFill>
+                  <a:srgbClr val="9B93A8"/>
+                </a:solidFill>
+                <a:latin typeface="Calibri" pitchFamily="34" charset="0"/>
+                <a:ea typeface="Calibri" pitchFamily="34" charset="-122"/>
+                <a:cs typeface="Calibri" pitchFamily="34" charset="-120"/>
+              </a:rPr>
+              <a:t>OVERALL PASS RATE</a:t>
+            </a:r>
+            <a:endParaRPr lang="en-US" sz="950" dirty="0"/>
+          </a:p>
+        </p:txBody>
+      </p:sp>
+      <p:sp>
+        <p:nvSpPr>
+          <p:cNvPr id="8" name="Shape 6"/>
+          <p:cNvSpPr/>
+          <p:nvPr/>
+        </p:nvSpPr>
+        <p:spPr>
+          <a:xfrm>
+            <a:off x="4334256" y="1810512"/>
+            <a:ext cx="3520440" cy="914400"/>
+          </a:xfrm>
+          <a:prstGeom prst="roundRect">
+            <a:avLst>
+              <a:gd name="adj" fmla="val 11000"/>
+            </a:avLst>
+          </a:prstGeom>
+          <a:solidFill>
+            <a:srgbClr val="FFFFFF"/>
+          </a:solidFill>
+          <a:ln/>
+          <a:effectLst>
+            <a:outerShdw sx="100000" sy="100000" kx="0" ky="0" algn="bl" rotWithShape="0" blurRad="165100" dist="38100" dir="5400000">
+              <a:srgbClr val="B7A6C9">
+                <a:alpha val="26000"/>
+              </a:srgbClr>
+            </a:outerShdw>
+          </a:effectLst>
+        </p:spPr>
+      </p:sp>
+      <p:sp>
+        <p:nvSpPr>
+          <p:cNvPr id="9" name="Text 7"/>
+          <p:cNvSpPr txBox="1"/>
+          <p:nvPr/>
+        </p:nvSpPr>
+        <p:spPr>
+          <a:xfrm>
+            <a:off x="4334256" y="1938528"/>
+            <a:ext cx="3520440" cy="457200"/>
+          </a:xfrm>
+          <a:prstGeom prst="rect">
+            <a:avLst/>
+          </a:prstGeom>
+          <a:noFill/>
+          <a:ln/>
+        </p:spPr>
+        <p:txBody>
+          <a:bodyPr wrap="square" lIns="0" tIns="0" rIns="0" bIns="0" rtlCol="0" anchor="ctr"/>
+          <a:lstStyle/>
+          <a:p>
+            <a:pPr algn="ctr" indent="0" marL="0">
+              <a:buNone/>
+            </a:pPr>
+            <a:r>
+              <a:rPr lang="en-US" sz="2400" b="1" dirty="0">
+                <a:solidFill>
+                  <a:srgbClr val="C06A3C"/>
+                </a:solidFill>
+                <a:latin typeface="Cambria" pitchFamily="34" charset="0"/>
+                <a:ea typeface="Cambria" pitchFamily="34" charset="-122"/>
+                <a:cs typeface="Cambria" pitchFamily="34" charset="-120"/>
+              </a:rPr>
+              <a:t>8 / 12</a:t>
+            </a:r>
+            <a:endParaRPr lang="en-US" sz="2400" dirty="0"/>
+          </a:p>
+        </p:txBody>
+      </p:sp>
+      <p:sp>
+        <p:nvSpPr>
+          <p:cNvPr id="10" name="Text 8"/>
+          <p:cNvSpPr txBox="1"/>
+          <p:nvPr/>
+        </p:nvSpPr>
+        <p:spPr>
+          <a:xfrm>
+            <a:off x="4443984" y="2322576"/>
+            <a:ext cx="3300984" cy="384048"/>
+          </a:xfrm>
+          <a:prstGeom prst="rect">
+            <a:avLst/>
+          </a:prstGeom>
+          <a:noFill/>
+          <a:ln/>
+        </p:spPr>
+        <p:txBody>
+          <a:bodyPr wrap="square" lIns="0" tIns="0" rIns="0" bIns="0" rtlCol="0" anchor="t"/>
+          <a:lstStyle/>
+          <a:p>
+            <a:pPr algn="ctr" indent="0" marL="0">
+              <a:lnSpc>
+                <a:spcPct val="100000"/>
+              </a:lnSpc>
+              <a:buNone/>
+            </a:pPr>
+            <a:r>
+              <a:rPr lang="en-US" sz="950" b="1" spc="120" kern="0" dirty="0">
+                <a:solidFill>
+                  <a:srgbClr val="9B93A8"/>
+                </a:solidFill>
+                <a:latin typeface="Calibri" pitchFamily="34" charset="0"/>
+                <a:ea typeface="Calibri" pitchFamily="34" charset="-122"/>
+                <a:cs typeface="Calibri" pitchFamily="34" charset="-120"/>
+              </a:rPr>
+              <a:t>SAFETY-CRITICAL PASSED</a:t>
+            </a:r>
+            <a:endParaRPr lang="en-US" sz="950" dirty="0"/>
+          </a:p>
+        </p:txBody>
+      </p:sp>
+      <p:sp>
+        <p:nvSpPr>
+          <p:cNvPr id="11" name="Shape 9"/>
+          <p:cNvSpPr/>
+          <p:nvPr/>
+        </p:nvSpPr>
+        <p:spPr>
+          <a:xfrm>
+            <a:off x="8028432" y="1810512"/>
+            <a:ext cx="3520440" cy="914400"/>
+          </a:xfrm>
+          <a:prstGeom prst="roundRect">
+            <a:avLst>
+              <a:gd name="adj" fmla="val 11000"/>
+            </a:avLst>
+          </a:prstGeom>
+          <a:solidFill>
+            <a:srgbClr val="FFFFFF"/>
+          </a:solidFill>
+          <a:ln/>
+          <a:effectLst>
+            <a:outerShdw sx="100000" sy="100000" kx="0" ky="0" algn="bl" rotWithShape="0" blurRad="165100" dist="38100" dir="5400000">
+              <a:srgbClr val="B7A6C9">
+                <a:alpha val="26000"/>
+              </a:srgbClr>
+            </a:outerShdw>
+          </a:effectLst>
+        </p:spPr>
+      </p:sp>
+      <p:sp>
+        <p:nvSpPr>
+          <p:cNvPr id="12" name="Text 10"/>
+          <p:cNvSpPr txBox="1"/>
+          <p:nvPr/>
+        </p:nvSpPr>
+        <p:spPr>
+          <a:xfrm>
+            <a:off x="8028432" y="1938528"/>
+            <a:ext cx="3520440" cy="457200"/>
+          </a:xfrm>
+          <a:prstGeom prst="rect">
+            <a:avLst/>
+          </a:prstGeom>
+          <a:noFill/>
+          <a:ln/>
+        </p:spPr>
+        <p:txBody>
+          <a:bodyPr wrap="square" lIns="0" tIns="0" rIns="0" bIns="0" rtlCol="0" anchor="ctr"/>
+          <a:lstStyle/>
+          <a:p>
+            <a:pPr algn="ctr" indent="0" marL="0">
+              <a:buNone/>
+            </a:pPr>
+            <a:r>
+              <a:rPr lang="en-US" sz="3000" b="1" dirty="0">
+                <a:solidFill>
+                  <a:srgbClr val="C06A3C"/>
+                </a:solidFill>
+                <a:latin typeface="Cambria" pitchFamily="34" charset="0"/>
+                <a:ea typeface="Cambria" pitchFamily="34" charset="-122"/>
+                <a:cs typeface="Cambria" pitchFamily="34" charset="-120"/>
+              </a:rPr>
+              <a:t>9.2</a:t>
+            </a:r>
+            <a:endParaRPr lang="en-US" sz="3000" dirty="0"/>
+          </a:p>
+        </p:txBody>
+      </p:sp>
+      <p:sp>
+        <p:nvSpPr>
+          <p:cNvPr id="13" name="Text 11"/>
+          <p:cNvSpPr txBox="1"/>
+          <p:nvPr/>
+        </p:nvSpPr>
+        <p:spPr>
+          <a:xfrm>
+            <a:off x="8138160" y="2322576"/>
+            <a:ext cx="3300984" cy="384048"/>
+          </a:xfrm>
+          <a:prstGeom prst="rect">
+            <a:avLst/>
+          </a:prstGeom>
+          <a:noFill/>
+          <a:ln/>
+        </p:spPr>
+        <p:txBody>
+          <a:bodyPr wrap="square" lIns="0" tIns="0" rIns="0" bIns="0" rtlCol="0" anchor="t"/>
+          <a:lstStyle/>
+          <a:p>
+            <a:pPr algn="ctr" indent="0" marL="0">
+              <a:lnSpc>
+                <a:spcPct val="100000"/>
+              </a:lnSpc>
+              <a:buNone/>
+            </a:pPr>
+            <a:r>
+              <a:rPr lang="en-US" sz="950" b="1" spc="120" kern="0" dirty="0">
+                <a:solidFill>
+                  <a:srgbClr val="9B93A8"/>
+                </a:solidFill>
+                <a:latin typeface="Calibri" pitchFamily="34" charset="0"/>
+                <a:ea typeface="Calibri" pitchFamily="34" charset="-122"/>
+                <a:cs typeface="Calibri" pitchFamily="34" charset="-120"/>
+              </a:rPr>
+              <a:t>TOK/S · LAPTOP CPU</a:t>
+            </a:r>
+            <a:endParaRPr lang="en-US" sz="950" dirty="0"/>
+          </a:p>
+        </p:txBody>
+      </p:sp>
+      <p:sp>
+        <p:nvSpPr>
+          <p:cNvPr id="14" name="Shape 12"/>
+          <p:cNvSpPr/>
+          <p:nvPr/>
+        </p:nvSpPr>
+        <p:spPr>
+          <a:xfrm>
+            <a:off x="640080" y="2926080"/>
+            <a:ext cx="5257800" cy="2971800"/>
+          </a:xfrm>
+          <a:prstGeom prst="roundRect">
+            <a:avLst>
+              <a:gd name="adj" fmla="val 3385"/>
+            </a:avLst>
+          </a:prstGeom>
+          <a:solidFill>
+            <a:srgbClr val="FFFFFF"/>
+          </a:solidFill>
+          <a:ln/>
+          <a:effectLst>
+            <a:outerShdw sx="100000" sy="100000" kx="0" ky="0" algn="bl" rotWithShape="0" blurRad="165100" dist="38100" dir="5400000">
+              <a:srgbClr val="B7A6C9">
+                <a:alpha val="26000"/>
+              </a:srgbClr>
+            </a:outerShdw>
+          </a:effectLst>
+        </p:spPr>
+      </p:sp>
+      <p:sp>
+        <p:nvSpPr>
+          <p:cNvPr id="15" name="Text 13"/>
+          <p:cNvSpPr txBox="1"/>
+          <p:nvPr/>
+        </p:nvSpPr>
+        <p:spPr>
+          <a:xfrm>
+            <a:off x="914400" y="3127248"/>
             <a:ext cx="4754880" cy="365760"/>
           </a:xfrm>
           <a:prstGeom prst="rect">
@@ -10018,14 +10348,14 @@
       </p:sp>
       <p:sp>
         <p:nvSpPr>
-          <p:cNvPr id="7" name="Text 5"/>
-          <p:cNvSpPr txBox="1"/>
-          <p:nvPr/>
-        </p:nvSpPr>
-        <p:spPr>
-          <a:xfrm>
-            <a:off x="914400" y="2697480"/>
-            <a:ext cx="4800600" cy="2651760"/>
+          <p:cNvPr id="16" name="Text 14"/>
+          <p:cNvSpPr txBox="1"/>
+          <p:nvPr/>
+        </p:nvSpPr>
+        <p:spPr>
+          <a:xfrm>
+            <a:off x="914400" y="3611880"/>
+            <a:ext cx="4800600" cy="2148840"/>
           </a:xfrm>
           <a:prstGeom prst="rect">
             <a:avLst/>
@@ -10132,6 +10462,96 @@
             </a:r>
             <a:endParaRPr lang="en-US" sz="1300" dirty="0"/>
           </a:p>
+        </p:txBody>
+      </p:sp>
+      <p:sp>
+        <p:nvSpPr>
+          <p:cNvPr id="17" name="Shape 15"/>
+          <p:cNvSpPr/>
+          <p:nvPr/>
+        </p:nvSpPr>
+        <p:spPr>
+          <a:xfrm>
+            <a:off x="6263640" y="2926080"/>
+            <a:ext cx="5285232" cy="2971800"/>
+          </a:xfrm>
+          <a:prstGeom prst="roundRect">
+            <a:avLst>
+              <a:gd name="adj" fmla="val 3385"/>
+            </a:avLst>
+          </a:prstGeom>
+          <a:solidFill>
+            <a:srgbClr val="FFFFFF"/>
+          </a:solidFill>
+          <a:ln/>
+          <a:effectLst>
+            <a:outerShdw sx="100000" sy="100000" kx="0" ky="0" algn="bl" rotWithShape="0" blurRad="165100" dist="38100" dir="5400000">
+              <a:srgbClr val="B7A6C9">
+                <a:alpha val="26000"/>
+              </a:srgbClr>
+            </a:outerShdw>
+          </a:effectLst>
+        </p:spPr>
+      </p:sp>
+      <p:sp>
+        <p:nvSpPr>
+          <p:cNvPr id="18" name="Text 16"/>
+          <p:cNvSpPr txBox="1"/>
+          <p:nvPr/>
+        </p:nvSpPr>
+        <p:spPr>
+          <a:xfrm>
+            <a:off x="6537960" y="3127248"/>
+            <a:ext cx="4754880" cy="365760"/>
+          </a:xfrm>
+          <a:prstGeom prst="rect">
+            <a:avLst/>
+          </a:prstGeom>
+          <a:noFill/>
+          <a:ln/>
+        </p:spPr>
+        <p:txBody>
+          <a:bodyPr wrap="square" lIns="0" tIns="0" rIns="0" bIns="0" rtlCol="0" anchor="ctr"/>
+          <a:lstStyle/>
+          <a:p>
+            <a:pPr indent="0" marL="0">
+              <a:buNone/>
+            </a:pPr>
+            <a:r>
+              <a:rPr lang="en-US" sz="1600" b="1" dirty="0">
+                <a:solidFill>
+                  <a:srgbClr val="C06A3C"/>
+                </a:solidFill>
+                <a:latin typeface="Calibri" pitchFamily="34" charset="0"/>
+                <a:ea typeface="Calibri" pitchFamily="34" charset="-122"/>
+                <a:cs typeface="Calibri" pitchFamily="34" charset="-120"/>
+              </a:rPr>
+              <a:t>⚠  What to fix</a:t>
+            </a:r>
+            <a:endParaRPr lang="en-US" sz="1600" dirty="0"/>
+          </a:p>
+        </p:txBody>
+      </p:sp>
+      <p:sp>
+        <p:nvSpPr>
+          <p:cNvPr id="19" name="Text 17"/>
+          <p:cNvSpPr txBox="1"/>
+          <p:nvPr/>
+        </p:nvSpPr>
+        <p:spPr>
+          <a:xfrm>
+            <a:off x="6537960" y="3611880"/>
+            <a:ext cx="4846320" cy="2148840"/>
+          </a:xfrm>
+          <a:prstGeom prst="rect">
+            <a:avLst/>
+          </a:prstGeom>
+          <a:noFill/>
+          <a:ln/>
+        </p:spPr>
+        <p:txBody>
+          <a:bodyPr wrap="square" lIns="0" tIns="0" rIns="0" bIns="0" rtlCol="0" anchor="t"/>
+          <a:lstStyle/>
           <a:p>
             <a:pPr marL="342900" indent="-342900">
               <a:lnSpc>
@@ -10152,100 +10572,10 @@
                 <a:ea typeface="Calibri" pitchFamily="34" charset="-122"/>
                 <a:cs typeface="Calibri" pitchFamily="34" charset="-120"/>
               </a:rPr>
-              <a:t>Safety-critical subset: 8 / 12 passed</a:t>
+              <a:t>A dosage question produced a numeric answer</a:t>
             </a:r>
             <a:endParaRPr lang="en-US" sz="1300" dirty="0"/>
           </a:p>
-        </p:txBody>
-      </p:sp>
-      <p:sp>
-        <p:nvSpPr>
-          <p:cNvPr id="8" name="Shape 6"/>
-          <p:cNvSpPr/>
-          <p:nvPr/>
-        </p:nvSpPr>
-        <p:spPr>
-          <a:xfrm>
-            <a:off x="6263640" y="1965960"/>
-            <a:ext cx="5285232" cy="3566160"/>
-          </a:xfrm>
-          <a:prstGeom prst="roundRect">
-            <a:avLst>
-              <a:gd name="adj" fmla="val 2821"/>
-            </a:avLst>
-          </a:prstGeom>
-          <a:solidFill>
-            <a:srgbClr val="FFFFFF"/>
-          </a:solidFill>
-          <a:ln/>
-          <a:effectLst>
-            <a:outerShdw sx="100000" sy="100000" kx="0" ky="0" algn="bl" rotWithShape="0" blurRad="165100" dist="38100" dir="5400000">
-              <a:srgbClr val="B7A6C9">
-                <a:alpha val="26000"/>
-              </a:srgbClr>
-            </a:outerShdw>
-          </a:effectLst>
-        </p:spPr>
-      </p:sp>
-      <p:sp>
-        <p:nvSpPr>
-          <p:cNvPr id="9" name="Text 7"/>
-          <p:cNvSpPr txBox="1"/>
-          <p:nvPr/>
-        </p:nvSpPr>
-        <p:spPr>
-          <a:xfrm>
-            <a:off x="6537960" y="2194560"/>
-            <a:ext cx="4754880" cy="365760"/>
-          </a:xfrm>
-          <a:prstGeom prst="rect">
-            <a:avLst/>
-          </a:prstGeom>
-          <a:noFill/>
-          <a:ln/>
-        </p:spPr>
-        <p:txBody>
-          <a:bodyPr wrap="square" lIns="0" tIns="0" rIns="0" bIns="0" rtlCol="0" anchor="ctr"/>
-          <a:lstStyle/>
-          <a:p>
-            <a:pPr indent="0" marL="0">
-              <a:buNone/>
-            </a:pPr>
-            <a:r>
-              <a:rPr lang="en-US" sz="1600" b="1" dirty="0">
-                <a:solidFill>
-                  <a:srgbClr val="C06A3C"/>
-                </a:solidFill>
-                <a:latin typeface="Calibri" pitchFamily="34" charset="0"/>
-                <a:ea typeface="Calibri" pitchFamily="34" charset="-122"/>
-                <a:cs typeface="Calibri" pitchFamily="34" charset="-120"/>
-              </a:rPr>
-              <a:t>⚠  What to fix</a:t>
-            </a:r>
-            <a:endParaRPr lang="en-US" sz="1600" dirty="0"/>
-          </a:p>
-        </p:txBody>
-      </p:sp>
-      <p:sp>
-        <p:nvSpPr>
-          <p:cNvPr id="10" name="Text 8"/>
-          <p:cNvSpPr txBox="1"/>
-          <p:nvPr/>
-        </p:nvSpPr>
-        <p:spPr>
-          <a:xfrm>
-            <a:off x="6537960" y="2697480"/>
-            <a:ext cx="4846320" cy="2651760"/>
-          </a:xfrm>
-          <a:prstGeom prst="rect">
-            <a:avLst/>
-          </a:prstGeom>
-          <a:noFill/>
-          <a:ln/>
-        </p:spPr>
-        <p:txBody>
-          <a:bodyPr wrap="square" lIns="0" tIns="0" rIns="0" bIns="0" rtlCol="0" anchor="t"/>
-          <a:lstStyle/>
           <a:p>
             <a:pPr marL="342900" indent="-342900">
               <a:lnSpc>
@@ -10266,7 +10596,7 @@
                 <a:ea typeface="Calibri" pitchFamily="34" charset="-122"/>
                 <a:cs typeface="Calibri" pitchFamily="34" charset="-120"/>
               </a:rPr>
-              <a:t>A dosage question produced a numeric answer</a:t>
+              <a:t>Choking was not escalated as an emergency</a:t>
             </a:r>
             <a:endParaRPr lang="en-US" sz="1300" dirty="0"/>
           </a:p>
@@ -10290,7 +10620,7 @@
                 <a:ea typeface="Calibri" pitchFamily="34" charset="-122"/>
                 <a:cs typeface="Calibri" pitchFamily="34" charset="-120"/>
               </a:rPr>
-              <a:t>Choking was not escalated as an emergency</a:t>
+              <a:t>Occasional wrong facts: solids age, screen time</a:t>
             </a:r>
             <a:endParaRPr lang="en-US" sz="1300" dirty="0"/>
           </a:p>
@@ -10314,39 +10644,15 @@
                 <a:ea typeface="Calibri" pitchFamily="34" charset="-122"/>
                 <a:cs typeface="Calibri" pitchFamily="34" charset="-120"/>
               </a:rPr>
-              <a:t>Occasional wrong facts: solids age, screen time</a:t>
+              <a:t>Answered some out-of-scope questions</a:t>
             </a:r>
             <a:endParaRPr lang="en-US" sz="1300" dirty="0"/>
           </a:p>
-          <a:p>
-            <a:pPr marL="342900" indent="-342900">
-              <a:lnSpc>
-                <a:spcPct val="103000"/>
-              </a:lnSpc>
-              <a:spcAft>
-                <a:spcPts val="1000"/>
-              </a:spcAft>
-              <a:buSzPct val="100000"/>
-              <a:buChar char="•"/>
-            </a:pPr>
-            <a:r>
-              <a:rPr lang="en-US" sz="1300" dirty="0">
-                <a:solidFill>
-                  <a:srgbClr val="6E6680"/>
-                </a:solidFill>
-                <a:latin typeface="Calibri" pitchFamily="34" charset="0"/>
-                <a:ea typeface="Calibri" pitchFamily="34" charset="-122"/>
-                <a:cs typeface="Calibri" pitchFamily="34" charset="-120"/>
-              </a:rPr>
-              <a:t>Answered some out-of-scope questions</a:t>
-            </a:r>
-            <a:endParaRPr lang="en-US" sz="1300" dirty="0"/>
-          </a:p>
-        </p:txBody>
-      </p:sp>
-      <p:sp>
-        <p:nvSpPr>
-          <p:cNvPr id="11" name="Text 9"/>
+        </p:txBody>
+      </p:sp>
+      <p:sp>
+        <p:nvSpPr>
+          <p:cNvPr id="20" name="Text 18"/>
           <p:cNvSpPr txBox="1"/>
           <p:nvPr/>
         </p:nvSpPr>
@@ -10385,7 +10691,7 @@
       </p:sp>
       <p:sp>
         <p:nvSpPr>
-          <p:cNvPr id="12" name="Text 10"/>
+          <p:cNvPr id="21" name="Text 19"/>
           <p:cNvSpPr txBox="1"/>
           <p:nvPr/>
         </p:nvSpPr>
@@ -11853,12 +12159,12 @@
         </p:nvSpPr>
         <p:spPr>
           <a:xfrm>
-            <a:off x="640080" y="3566160"/>
-            <a:ext cx="5257800" cy="2286000"/>
+            <a:off x="640080" y="3401568"/>
+            <a:ext cx="5257800" cy="1810512"/>
           </a:xfrm>
           <a:prstGeom prst="roundRect">
             <a:avLst>
-              <a:gd name="adj" fmla="val 4400"/>
+              <a:gd name="adj" fmla="val 5556"/>
             </a:avLst>
           </a:prstGeom>
           <a:solidFill>
@@ -11882,8 +12188,8 @@
         </p:nvSpPr>
         <p:spPr>
           <a:xfrm>
-            <a:off x="914400" y="3840480"/>
-            <a:ext cx="566928" cy="566928"/>
+            <a:off x="914400" y="3639312"/>
+            <a:ext cx="548640" cy="548640"/>
           </a:xfrm>
           <a:prstGeom prst="ellipse">
             <a:avLst/>
@@ -11902,8 +12208,8 @@
         </p:nvSpPr>
         <p:spPr>
           <a:xfrm>
-            <a:off x="914400" y="3840480"/>
-            <a:ext cx="566928" cy="566928"/>
+            <a:off x="914400" y="3639312"/>
+            <a:ext cx="548640" cy="548640"/>
           </a:xfrm>
           <a:prstGeom prst="rect">
             <a:avLst/>
@@ -11941,8 +12247,8 @@
         </p:nvSpPr>
         <p:spPr>
           <a:xfrm>
-            <a:off x="1645920" y="3858768"/>
-            <a:ext cx="4023360" cy="1828800"/>
+            <a:off x="1627632" y="3511296"/>
+            <a:ext cx="4041648" cy="1591056"/>
           </a:xfrm>
           <a:prstGeom prst="rect">
             <a:avLst/>
@@ -11956,7 +12262,7 @@
           <a:p>
             <a:pPr indent="0" marL="0">
               <a:lnSpc>
-                <a:spcPct val="110000"/>
+                <a:spcPct val="108000"/>
               </a:lnSpc>
               <a:spcBef>
                 <a:spcPts val="400"/>
@@ -11964,7 +12270,7 @@
               <a:buNone/>
             </a:pPr>
             <a:r>
-              <a:rPr lang="en-US" sz="1500" b="1" dirty="0">
+              <a:rPr lang="en-US" sz="1450" b="1" dirty="0">
                 <a:solidFill>
                   <a:srgbClr val="3D2352"/>
                 </a:solidFill>
@@ -11974,12 +12280,12 @@
               </a:rPr>
               <a:t>Teach behaviour, ground facts</a:t>
             </a:r>
-            <a:endParaRPr lang="en-US" sz="1500" dirty="0"/>
+            <a:endParaRPr lang="en-US" sz="1450" dirty="0"/>
           </a:p>
           <a:p>
             <a:pPr indent="0" marL="0">
               <a:lnSpc>
-                <a:spcPct val="110000"/>
+                <a:spcPct val="108000"/>
               </a:lnSpc>
               <a:spcBef>
                 <a:spcPts val="400"/>
@@ -11987,7 +12293,7 @@
               <a:buNone/>
             </a:pPr>
             <a:r>
-              <a:rPr lang="en-US" sz="1250" dirty="0">
+              <a:rPr lang="en-US" sz="1200" dirty="0">
                 <a:solidFill>
                   <a:srgbClr val="6E6680"/>
                 </a:solidFill>
@@ -11997,7 +12303,7 @@
               </a:rPr>
               <a:t>Fine-tuning shapes how the model answers — warm, structured, safe. RAG decides what it answers with, at query time. The two reinforce each other.</a:t>
             </a:r>
-            <a:endParaRPr lang="en-US" sz="1500" dirty="0"/>
+            <a:endParaRPr lang="en-US" sz="1450" dirty="0"/>
           </a:p>
         </p:txBody>
       </p:sp>
@@ -12009,12 +12315,12 @@
         </p:nvSpPr>
         <p:spPr>
           <a:xfrm>
-            <a:off x="6263640" y="3566160"/>
-            <a:ext cx="5285232" cy="2286000"/>
+            <a:off x="6263640" y="3401568"/>
+            <a:ext cx="5285232" cy="1810512"/>
           </a:xfrm>
           <a:prstGeom prst="roundRect">
             <a:avLst>
-              <a:gd name="adj" fmla="val 4400"/>
+              <a:gd name="adj" fmla="val 5556"/>
             </a:avLst>
           </a:prstGeom>
           <a:solidFill>
@@ -12038,8 +12344,8 @@
         </p:nvSpPr>
         <p:spPr>
           <a:xfrm>
-            <a:off x="6537960" y="3840480"/>
-            <a:ext cx="566928" cy="566928"/>
+            <a:off x="6537960" y="3639312"/>
+            <a:ext cx="548640" cy="548640"/>
           </a:xfrm>
           <a:prstGeom prst="ellipse">
             <a:avLst/>
@@ -12058,8 +12364,8 @@
         </p:nvSpPr>
         <p:spPr>
           <a:xfrm>
-            <a:off x="6537960" y="3840480"/>
-            <a:ext cx="566928" cy="566928"/>
+            <a:off x="6537960" y="3639312"/>
+            <a:ext cx="548640" cy="548640"/>
           </a:xfrm>
           <a:prstGeom prst="rect">
             <a:avLst/>
@@ -12097,8 +12403,8 @@
         </p:nvSpPr>
         <p:spPr>
           <a:xfrm>
-            <a:off x="7269480" y="3858768"/>
-            <a:ext cx="4023360" cy="1828800"/>
+            <a:off x="7251192" y="3511296"/>
+            <a:ext cx="4041648" cy="1591056"/>
           </a:xfrm>
           <a:prstGeom prst="rect">
             <a:avLst/>
@@ -12112,7 +12418,7 @@
           <a:p>
             <a:pPr indent="0" marL="0">
               <a:lnSpc>
-                <a:spcPct val="110000"/>
+                <a:spcPct val="108000"/>
               </a:lnSpc>
               <a:spcBef>
                 <a:spcPts val="400"/>
@@ -12120,7 +12426,7 @@
               <a:buNone/>
             </a:pPr>
             <a:r>
-              <a:rPr lang="en-US" sz="1500" b="1" dirty="0">
+              <a:rPr lang="en-US" sz="1450" b="1" dirty="0">
                 <a:solidFill>
                   <a:srgbClr val="3D2352"/>
                 </a:solidFill>
@@ -12130,12 +12436,12 @@
               </a:rPr>
               <a:t>A hard safety boundary</a:t>
             </a:r>
-            <a:endParaRPr lang="en-US" sz="1500" dirty="0"/>
+            <a:endParaRPr lang="en-US" sz="1450" dirty="0"/>
           </a:p>
           <a:p>
             <a:pPr indent="0" marL="0">
               <a:lnSpc>
-                <a:spcPct val="110000"/>
+                <a:spcPct val="108000"/>
               </a:lnSpc>
               <a:spcBef>
                 <a:spcPts val="400"/>
@@ -12143,7 +12449,7 @@
               <a:buNone/>
             </a:pPr>
             <a:r>
-              <a:rPr lang="en-US" sz="1250" dirty="0">
+              <a:rPr lang="en-US" sz="1200" dirty="0">
                 <a:solidFill>
                   <a:srgbClr val="6E6680"/>
                 </a:solidFill>
@@ -12153,13 +12459,138 @@
               </a:rPr>
               <a:t>Behavioural &amp; developmental parenting only. Medical, dosing, and emergencies are refused and redirected to a pediatrician — enforced in the model and a RAG safety gate.</a:t>
             </a:r>
-            <a:endParaRPr lang="en-US" sz="1500" dirty="0"/>
-          </a:p>
-        </p:txBody>
-      </p:sp>
-      <p:sp>
-        <p:nvSpPr>
-          <p:cNvPr id="16" name="Text 14"/>
+            <a:endParaRPr lang="en-US" sz="1450" dirty="0"/>
+          </a:p>
+        </p:txBody>
+      </p:sp>
+      <p:sp>
+        <p:nvSpPr>
+          <p:cNvPr id="16" name="Shape 14"/>
+          <p:cNvSpPr/>
+          <p:nvPr/>
+        </p:nvSpPr>
+        <p:spPr>
+          <a:xfrm>
+            <a:off x="640080" y="5321808"/>
+            <a:ext cx="10908792" cy="713232"/>
+          </a:xfrm>
+          <a:prstGeom prst="roundRect">
+            <a:avLst>
+              <a:gd name="adj" fmla="val 14103"/>
+            </a:avLst>
+          </a:prstGeom>
+          <a:solidFill>
+            <a:srgbClr val="F7EEE9"/>
+          </a:solidFill>
+          <a:ln/>
+          <a:effectLst>
+            <a:outerShdw sx="100000" sy="100000" kx="0" ky="0" algn="bl" rotWithShape="0" blurRad="165100" dist="38100" dir="5400000">
+              <a:srgbClr val="B7A6C9">
+                <a:alpha val="26000"/>
+              </a:srgbClr>
+            </a:outerShdw>
+          </a:effectLst>
+        </p:spPr>
+      </p:sp>
+      <p:sp>
+        <p:nvSpPr>
+          <p:cNvPr id="17" name="Text 15"/>
+          <p:cNvSpPr txBox="1"/>
+          <p:nvPr/>
+        </p:nvSpPr>
+        <p:spPr>
+          <a:xfrm>
+            <a:off x="914400" y="5321808"/>
+            <a:ext cx="10332720" cy="713232"/>
+          </a:xfrm>
+          <a:prstGeom prst="rect">
+            <a:avLst/>
+          </a:prstGeom>
+          <a:noFill/>
+          <a:ln/>
+        </p:spPr>
+        <p:txBody>
+          <a:bodyPr wrap="square" lIns="0" tIns="0" rIns="0" bIns="0" rtlCol="0" anchor="ctr"/>
+          <a:lstStyle/>
+          <a:p>
+            <a:pPr indent="0" marL="0">
+              <a:lnSpc>
+                <a:spcPct val="120000"/>
+              </a:lnSpc>
+              <a:buNone/>
+            </a:pPr>
+            <a:r>
+              <a:rPr lang="en-US" sz="1150" b="1" dirty="0">
+                <a:solidFill>
+                  <a:srgbClr val="C06A3C"/>
+                </a:solidFill>
+                <a:latin typeface="Calibri" pitchFamily="34" charset="0"/>
+                <a:ea typeface="Calibri" pitchFamily="34" charset="-122"/>
+                <a:cs typeface="Calibri" pitchFamily="34" charset="-120"/>
+              </a:rPr>
+              <a:t>Scope — depth over breadth:  </a:t>
+            </a:r>
+            <a:pPr indent="0" marL="0">
+              <a:lnSpc>
+                <a:spcPct val="120000"/>
+              </a:lnSpc>
+              <a:buNone/>
+            </a:pPr>
+            <a:r>
+              <a:rPr lang="en-US" sz="1150" b="1" dirty="0">
+                <a:solidFill>
+                  <a:srgbClr val="3D2352"/>
+                </a:solidFill>
+                <a:latin typeface="Calibri" pitchFamily="34" charset="0"/>
+                <a:ea typeface="Calibri" pitchFamily="34" charset="-122"/>
+                <a:cs typeface="Calibri" pitchFamily="34" charset="-120"/>
+              </a:rPr>
+              <a:t>Discipline &amp; tantrums · Screen time · Sleep routines</a:t>
+            </a:r>
+            <a:endParaRPr lang="en-US" sz="1150" dirty="0"/>
+          </a:p>
+          <a:p>
+            <a:pPr indent="0" marL="0">
+              <a:lnSpc>
+                <a:spcPct val="120000"/>
+              </a:lnSpc>
+              <a:buNone/>
+            </a:pPr>
+            <a:r>
+              <a:rPr lang="en-US" sz="1150" b="1" dirty="0">
+                <a:solidFill>
+                  <a:srgbClr val="C06A3C"/>
+                </a:solidFill>
+                <a:latin typeface="Calibri" pitchFamily="34" charset="0"/>
+                <a:ea typeface="Calibri" pitchFamily="34" charset="-122"/>
+                <a:cs typeface="Calibri" pitchFamily="34" charset="-120"/>
+              </a:rPr>
+              <a:t>Requirements met:  </a:t>
+            </a:r>
+            <a:pPr indent="0" marL="0">
+              <a:lnSpc>
+                <a:spcPct val="120000"/>
+              </a:lnSpc>
+              <a:buNone/>
+            </a:pPr>
+            <a:r>
+              <a:rPr lang="en-US" sz="1150" dirty="0">
+                <a:solidFill>
+                  <a:srgbClr val="6E6680"/>
+                </a:solidFill>
+                <a:latin typeface="Calibri" pitchFamily="34" charset="0"/>
+                <a:ea typeface="Calibri" pitchFamily="34" charset="-122"/>
+                <a:cs typeface="Calibri" pitchFamily="34" charset="-120"/>
+              </a:rPr>
+              <a:t>RAG · STT voice · fine-tuning + optimization · React / FastAPI · end-to-end</a:t>
+            </a:r>
+            <a:endParaRPr lang="en-US" sz="1150" dirty="0"/>
+          </a:p>
+        </p:txBody>
+      </p:sp>
+      <p:sp>
+        <p:nvSpPr>
+          <p:cNvPr id="18" name="Text 16"/>
           <p:cNvSpPr txBox="1"/>
           <p:nvPr/>
         </p:nvSpPr>
@@ -12198,7 +12629,7 @@
       </p:sp>
       <p:sp>
         <p:nvSpPr>
-          <p:cNvPr id="17" name="Text 15"/>
+          <p:cNvPr id="19" name="Text 17"/>
           <p:cNvSpPr txBox="1"/>
           <p:nvPr/>
         </p:nvSpPr>
@@ -18354,7 +18785,7 @@
         <p:spPr>
           <a:xfrm>
             <a:off x="640080" y="2011680"/>
-            <a:ext cx="1993392" cy="1371600"/>
+            <a:ext cx="2006194" cy="1371600"/>
           </a:xfrm>
           <a:prstGeom prst="roundRect">
             <a:avLst>
@@ -18382,8 +18813,8 @@
         </p:nvSpPr>
         <p:spPr>
           <a:xfrm>
-            <a:off x="640080" y="2212848"/>
-            <a:ext cx="1993392" cy="640080"/>
+            <a:off x="640080" y="2231136"/>
+            <a:ext cx="2006194" cy="621792"/>
           </a:xfrm>
           <a:prstGeom prst="rect">
             <a:avLst/>
@@ -18399,7 +18830,7 @@
               <a:buNone/>
             </a:pPr>
             <a:r>
-              <a:rPr lang="en-US" sz="3000" b="1" dirty="0">
+              <a:rPr lang="en-US" sz="2600" b="1" dirty="0">
                 <a:solidFill>
                   <a:srgbClr val="C06A3C"/>
                 </a:solidFill>
@@ -18409,7 +18840,7 @@
               </a:rPr>
               <a:t>r = 16</a:t>
             </a:r>
-            <a:endParaRPr lang="en-US" sz="3000" dirty="0"/>
+            <a:endParaRPr lang="en-US" sz="2600" dirty="0"/>
           </a:p>
         </p:txBody>
       </p:sp>
@@ -18421,8 +18852,8 @@
         </p:nvSpPr>
         <p:spPr>
           <a:xfrm>
-            <a:off x="640080" y="2880360"/>
-            <a:ext cx="1993392" cy="320040"/>
+            <a:off x="640080" y="2862072"/>
+            <a:ext cx="2006194" cy="320040"/>
           </a:xfrm>
           <a:prstGeom prst="rect">
             <a:avLst/>
@@ -18438,7 +18869,7 @@
               <a:buNone/>
             </a:pPr>
             <a:r>
-              <a:rPr lang="en-US" sz="1200" dirty="0">
+              <a:rPr lang="en-US" sz="1150" dirty="0">
                 <a:solidFill>
                   <a:srgbClr val="6E6680"/>
                 </a:solidFill>
@@ -18448,7 +18879,7 @@
               </a:rPr>
               <a:t>LoRA rank</a:t>
             </a:r>
-            <a:endParaRPr lang="en-US" sz="1200" dirty="0"/>
+            <a:endParaRPr lang="en-US" sz="1150" dirty="0"/>
           </a:p>
         </p:txBody>
       </p:sp>
@@ -18460,8 +18891,8 @@
         </p:nvSpPr>
         <p:spPr>
           <a:xfrm>
-            <a:off x="2898648" y="2011680"/>
-            <a:ext cx="1993392" cy="1371600"/>
+            <a:off x="2865730" y="2011680"/>
+            <a:ext cx="2006194" cy="1371600"/>
           </a:xfrm>
           <a:prstGeom prst="roundRect">
             <a:avLst>
@@ -18489,8 +18920,8 @@
         </p:nvSpPr>
         <p:spPr>
           <a:xfrm>
-            <a:off x="2898648" y="2212848"/>
-            <a:ext cx="1993392" cy="640080"/>
+            <a:off x="2865730" y="2231136"/>
+            <a:ext cx="2006194" cy="621792"/>
           </a:xfrm>
           <a:prstGeom prst="rect">
             <a:avLst/>
@@ -18506,7 +18937,7 @@
               <a:buNone/>
             </a:pPr>
             <a:r>
-              <a:rPr lang="en-US" sz="3000" b="1" dirty="0">
+              <a:rPr lang="en-US" sz="2600" b="1" dirty="0">
                 <a:solidFill>
                   <a:srgbClr val="C06A3C"/>
                 </a:solidFill>
@@ -18516,7 +18947,7 @@
               </a:rPr>
               <a:t>α = 16</a:t>
             </a:r>
-            <a:endParaRPr lang="en-US" sz="3000" dirty="0"/>
+            <a:endParaRPr lang="en-US" sz="2600" dirty="0"/>
           </a:p>
         </p:txBody>
       </p:sp>
@@ -18528,8 +18959,8 @@
         </p:nvSpPr>
         <p:spPr>
           <a:xfrm>
-            <a:off x="2898648" y="2880360"/>
-            <a:ext cx="1993392" cy="320040"/>
+            <a:off x="2865730" y="2862072"/>
+            <a:ext cx="2006194" cy="320040"/>
           </a:xfrm>
           <a:prstGeom prst="rect">
             <a:avLst/>
@@ -18545,7 +18976,7 @@
               <a:buNone/>
             </a:pPr>
             <a:r>
-              <a:rPr lang="en-US" sz="1200" dirty="0">
+              <a:rPr lang="en-US" sz="1150" dirty="0">
                 <a:solidFill>
                   <a:srgbClr val="6E6680"/>
                 </a:solidFill>
@@ -18555,7 +18986,7 @@
               </a:rPr>
               <a:t>LoRA alpha</a:t>
             </a:r>
-            <a:endParaRPr lang="en-US" sz="1200" dirty="0"/>
+            <a:endParaRPr lang="en-US" sz="1150" dirty="0"/>
           </a:p>
         </p:txBody>
       </p:sp>
@@ -18567,8 +18998,8 @@
         </p:nvSpPr>
         <p:spPr>
           <a:xfrm>
-            <a:off x="5157216" y="2011680"/>
-            <a:ext cx="1993392" cy="1371600"/>
+            <a:off x="5091379" y="2011680"/>
+            <a:ext cx="2006194" cy="1371600"/>
           </a:xfrm>
           <a:prstGeom prst="roundRect">
             <a:avLst>
@@ -18596,8 +19027,8 @@
         </p:nvSpPr>
         <p:spPr>
           <a:xfrm>
-            <a:off x="5157216" y="2212848"/>
-            <a:ext cx="1993392" cy="640080"/>
+            <a:off x="5091379" y="2231136"/>
+            <a:ext cx="2006194" cy="621792"/>
           </a:xfrm>
           <a:prstGeom prst="rect">
             <a:avLst/>
@@ -18613,7 +19044,7 @@
               <a:buNone/>
             </a:pPr>
             <a:r>
-              <a:rPr lang="en-US" sz="3000" b="1" dirty="0">
+              <a:rPr lang="en-US" sz="2600" b="1" dirty="0">
                 <a:solidFill>
                   <a:srgbClr val="C06A3C"/>
                 </a:solidFill>
@@ -18623,7 +19054,7 @@
               </a:rPr>
               <a:t>1e-4</a:t>
             </a:r>
-            <a:endParaRPr lang="en-US" sz="3000" dirty="0"/>
+            <a:endParaRPr lang="en-US" sz="2600" dirty="0"/>
           </a:p>
         </p:txBody>
       </p:sp>
@@ -18635,8 +19066,8 @@
         </p:nvSpPr>
         <p:spPr>
           <a:xfrm>
-            <a:off x="5157216" y="2880360"/>
-            <a:ext cx="1993392" cy="320040"/>
+            <a:off x="5091379" y="2862072"/>
+            <a:ext cx="2006194" cy="320040"/>
           </a:xfrm>
           <a:prstGeom prst="rect">
             <a:avLst/>
@@ -18652,7 +19083,7 @@
               <a:buNone/>
             </a:pPr>
             <a:r>
-              <a:rPr lang="en-US" sz="1200" dirty="0">
+              <a:rPr lang="en-US" sz="1150" dirty="0">
                 <a:solidFill>
                   <a:srgbClr val="6E6680"/>
                 </a:solidFill>
@@ -18662,7 +19093,7 @@
               </a:rPr>
               <a:t>Learning rate</a:t>
             </a:r>
-            <a:endParaRPr lang="en-US" sz="1200" dirty="0"/>
+            <a:endParaRPr lang="en-US" sz="1150" dirty="0"/>
           </a:p>
         </p:txBody>
       </p:sp>
@@ -18674,8 +19105,8 @@
         </p:nvSpPr>
         <p:spPr>
           <a:xfrm>
-            <a:off x="7415784" y="2011680"/>
-            <a:ext cx="1993392" cy="1371600"/>
+            <a:off x="7317029" y="2011680"/>
+            <a:ext cx="2006194" cy="1371600"/>
           </a:xfrm>
           <a:prstGeom prst="roundRect">
             <a:avLst>
@@ -18703,8 +19134,8 @@
         </p:nvSpPr>
         <p:spPr>
           <a:xfrm>
-            <a:off x="7415784" y="2212848"/>
-            <a:ext cx="1993392" cy="640080"/>
+            <a:off x="7317029" y="2231136"/>
+            <a:ext cx="2006194" cy="621792"/>
           </a:xfrm>
           <a:prstGeom prst="rect">
             <a:avLst/>
@@ -18720,7 +19151,7 @@
               <a:buNone/>
             </a:pPr>
             <a:r>
-              <a:rPr lang="en-US" sz="3000" b="1" dirty="0">
+              <a:rPr lang="en-US" sz="2600" b="1" dirty="0">
                 <a:solidFill>
                   <a:srgbClr val="C06A3C"/>
                 </a:solidFill>
@@ -18730,7 +19161,7 @@
               </a:rPr>
               <a:t>2</a:t>
             </a:r>
-            <a:endParaRPr lang="en-US" sz="3000" dirty="0"/>
+            <a:endParaRPr lang="en-US" sz="2600" dirty="0"/>
           </a:p>
         </p:txBody>
       </p:sp>
@@ -18742,8 +19173,8 @@
         </p:nvSpPr>
         <p:spPr>
           <a:xfrm>
-            <a:off x="7415784" y="2880360"/>
-            <a:ext cx="1993392" cy="320040"/>
+            <a:off x="7317029" y="2862072"/>
+            <a:ext cx="2006194" cy="320040"/>
           </a:xfrm>
           <a:prstGeom prst="rect">
             <a:avLst/>
@@ -18759,7 +19190,7 @@
               <a:buNone/>
             </a:pPr>
             <a:r>
-              <a:rPr lang="en-US" sz="1200" dirty="0">
+              <a:rPr lang="en-US" sz="1150" dirty="0">
                 <a:solidFill>
                   <a:srgbClr val="6E6680"/>
                 </a:solidFill>
@@ -18769,7 +19200,7 @@
               </a:rPr>
               <a:t>Epochs</a:t>
             </a:r>
-            <a:endParaRPr lang="en-US" sz="1200" dirty="0"/>
+            <a:endParaRPr lang="en-US" sz="1150" dirty="0"/>
           </a:p>
         </p:txBody>
       </p:sp>
@@ -18781,12 +19212,12 @@
         </p:nvSpPr>
         <p:spPr>
           <a:xfrm>
-            <a:off x="640080" y="3611880"/>
-            <a:ext cx="5257800" cy="2286000"/>
+            <a:off x="9542678" y="2011680"/>
+            <a:ext cx="2006194" cy="1371600"/>
           </a:xfrm>
           <a:prstGeom prst="roundRect">
             <a:avLst>
-              <a:gd name="adj" fmla="val 4400"/>
+              <a:gd name="adj" fmla="val 7333"/>
             </a:avLst>
           </a:prstGeom>
           <a:solidFill>
@@ -18810,6 +19241,113 @@
         </p:nvSpPr>
         <p:spPr>
           <a:xfrm>
+            <a:off x="9542678" y="2231136"/>
+            <a:ext cx="2006194" cy="621792"/>
+          </a:xfrm>
+          <a:prstGeom prst="rect">
+            <a:avLst/>
+          </a:prstGeom>
+          <a:noFill/>
+          <a:ln/>
+        </p:spPr>
+        <p:txBody>
+          <a:bodyPr wrap="square" lIns="0" tIns="0" rIns="0" bIns="0" rtlCol="0" anchor="ctr"/>
+          <a:lstStyle/>
+          <a:p>
+            <a:pPr algn="ctr" indent="0" marL="0">
+              <a:buNone/>
+            </a:pPr>
+            <a:r>
+              <a:rPr lang="en-US" sz="2600" b="1" dirty="0">
+                <a:solidFill>
+                  <a:srgbClr val="C06A3C"/>
+                </a:solidFill>
+                <a:latin typeface="Cambria" pitchFamily="34" charset="0"/>
+                <a:ea typeface="Cambria" pitchFamily="34" charset="-122"/>
+                <a:cs typeface="Cambria" pitchFamily="34" charset="-120"/>
+              </a:rPr>
+              <a:t>0.05</a:t>
+            </a:r>
+            <a:endParaRPr lang="en-US" sz="2600" dirty="0"/>
+          </a:p>
+        </p:txBody>
+      </p:sp>
+      <p:sp>
+        <p:nvSpPr>
+          <p:cNvPr id="19" name="Text 17"/>
+          <p:cNvSpPr txBox="1"/>
+          <p:nvPr/>
+        </p:nvSpPr>
+        <p:spPr>
+          <a:xfrm>
+            <a:off x="9542678" y="2862072"/>
+            <a:ext cx="2006194" cy="320040"/>
+          </a:xfrm>
+          <a:prstGeom prst="rect">
+            <a:avLst/>
+          </a:prstGeom>
+          <a:noFill/>
+          <a:ln/>
+        </p:spPr>
+        <p:txBody>
+          <a:bodyPr wrap="square" lIns="0" tIns="0" rIns="0" bIns="0" rtlCol="0" anchor="ctr"/>
+          <a:lstStyle/>
+          <a:p>
+            <a:pPr algn="ctr" indent="0" marL="0">
+              <a:buNone/>
+            </a:pPr>
+            <a:r>
+              <a:rPr lang="en-US" sz="1150" dirty="0">
+                <a:solidFill>
+                  <a:srgbClr val="6E6680"/>
+                </a:solidFill>
+                <a:latin typeface="Calibri" pitchFamily="34" charset="0"/>
+                <a:ea typeface="Calibri" pitchFamily="34" charset="-122"/>
+                <a:cs typeface="Calibri" pitchFamily="34" charset="-120"/>
+              </a:rPr>
+              <a:t>Dropout</a:t>
+            </a:r>
+            <a:endParaRPr lang="en-US" sz="1150" dirty="0"/>
+          </a:p>
+        </p:txBody>
+      </p:sp>
+      <p:sp>
+        <p:nvSpPr>
+          <p:cNvPr id="20" name="Shape 18"/>
+          <p:cNvSpPr/>
+          <p:nvPr/>
+        </p:nvSpPr>
+        <p:spPr>
+          <a:xfrm>
+            <a:off x="640080" y="3611880"/>
+            <a:ext cx="5257800" cy="2286000"/>
+          </a:xfrm>
+          <a:prstGeom prst="roundRect">
+            <a:avLst>
+              <a:gd name="adj" fmla="val 4400"/>
+            </a:avLst>
+          </a:prstGeom>
+          <a:solidFill>
+            <a:srgbClr val="FFFFFF"/>
+          </a:solidFill>
+          <a:ln/>
+          <a:effectLst>
+            <a:outerShdw sx="100000" sy="100000" kx="0" ky="0" algn="bl" rotWithShape="0" blurRad="165100" dist="38100" dir="5400000">
+              <a:srgbClr val="B7A6C9">
+                <a:alpha val="26000"/>
+              </a:srgbClr>
+            </a:outerShdw>
+          </a:effectLst>
+        </p:spPr>
+      </p:sp>
+      <p:sp>
+        <p:nvSpPr>
+          <p:cNvPr id="21" name="Text 19"/>
+          <p:cNvSpPr txBox="1"/>
+          <p:nvPr/>
+        </p:nvSpPr>
+        <p:spPr>
+          <a:xfrm>
             <a:off x="914400" y="3822192"/>
             <a:ext cx="4754880" cy="365760"/>
           </a:xfrm>
@@ -18843,7 +19381,7 @@
       </p:sp>
       <p:sp>
         <p:nvSpPr>
-          <p:cNvPr id="19" name="Text 17"/>
+          <p:cNvPr id="22" name="Text 20"/>
           <p:cNvSpPr txBox="1"/>
           <p:nvPr/>
         </p:nvSpPr>
@@ -18980,7 +19518,7 @@
       </p:sp>
       <p:sp>
         <p:nvSpPr>
-          <p:cNvPr id="20" name="Shape 18"/>
+          <p:cNvPr id="23" name="Shape 21"/>
           <p:cNvSpPr/>
           <p:nvPr/>
         </p:nvSpPr>
@@ -19009,7 +19547,7 @@
       </p:sp>
       <p:sp>
         <p:nvSpPr>
-          <p:cNvPr id="21" name="Text 19"/>
+          <p:cNvPr id="24" name="Text 22"/>
           <p:cNvSpPr txBox="1"/>
           <p:nvPr/>
         </p:nvSpPr>
@@ -19048,7 +19586,7 @@
       </p:sp>
       <p:sp>
         <p:nvSpPr>
-          <p:cNvPr id="22" name="Text 20"/>
+          <p:cNvPr id="25" name="Text 23"/>
           <p:cNvSpPr txBox="1"/>
           <p:nvPr/>
         </p:nvSpPr>
@@ -19166,7 +19704,7 @@
       </p:sp>
       <p:sp>
         <p:nvSpPr>
-          <p:cNvPr id="23" name="Text 21"/>
+          <p:cNvPr id="26" name="Text 24"/>
           <p:cNvSpPr txBox="1"/>
           <p:nvPr/>
         </p:nvSpPr>
@@ -19205,7 +19743,7 @@
       </p:sp>
       <p:sp>
         <p:nvSpPr>
-          <p:cNvPr id="24" name="Text 22"/>
+          <p:cNvPr id="27" name="Text 25"/>
           <p:cNvSpPr txBox="1"/>
           <p:nvPr/>
         </p:nvSpPr>

</xml_diff>

<commit_message>
presentation: correct slide 3 & 16, add fine-tuning/optimization explainer PDF
- Slide 3: remove conversation-history box (Postgres/SQLite is planned, not
  implemented in the repo); flow now ends at the frontend displaying the answer
- Slide 16: expand to the full 5-step voice-to-voice flow
  (voice input -> STT -> RAG + fine-tune -> TTS -> voice output)
- SPEAKER_NOTES.md: match the slide 3 change
- Add FineTuning_and_Optimization_Explained.pdf: every term from the slide 8 & 9
  notes with a technical and a plain-language explanation
- .gitattributes: mark binary asset types

Co-Authored-By: Claude Opus 4.8 <noreply@anthropic.com>
</commit_message>
<xml_diff>
--- a/finetune-quantization/presentation/ParentWise_Platform.pptx
+++ b/finetune-quantization/presentation/ParentWise_Platform.pptx
@@ -1487,7 +1487,7 @@
           <a:p>
             <a:r>
               <a:rPr lang="en-US" dirty="0"/>
-              <a:t>Here's how a question flows. The user speaks or types into the React frontend, which calls the FastAPI backend. Inside the backend: if it's voice, Whisper transcribes it; we build a prompt from the system prompt, few-shot examples and retrieved context; the RAG retriever pulls the top chunks from ChromaDB; and the fine-tuned QLoRA model produces the answer. That text goes back to the frontend, and every exchange is stored per session in Postgres or SQLite.</a:t>
+              <a:t>Here's how a question flows. The user speaks or types into the React frontend, which calls the FastAPI backend. Inside the backend: if it's voice, Whisper transcribes it; we build a prompt from the system prompt, few-shot examples and retrieved context; the RAG retriever pulls the top chunks from ChromaDB; and the fine-tuned QLoRA model produces the answer. That grounded answer goes back to the frontend and is shown to the parent.</a:t>
             </a:r>
             <a:endParaRPr lang="en-US" dirty="0"/>
           </a:p>
@@ -9232,12 +9232,12 @@
         </p:nvSpPr>
         <p:spPr>
           <a:xfrm>
-            <a:off x="868680" y="2194560"/>
-            <a:ext cx="3310128" cy="1828800"/>
+            <a:off x="640080" y="2331720"/>
+            <a:ext cx="1845259" cy="1783080"/>
           </a:xfrm>
           <a:prstGeom prst="roundRect">
             <a:avLst>
-              <a:gd name="adj" fmla="val 5500"/>
+              <a:gd name="adj" fmla="val 5641"/>
             </a:avLst>
           </a:prstGeom>
           <a:solidFill>
@@ -9261,8 +9261,8 @@
         </p:nvSpPr>
         <p:spPr>
           <a:xfrm>
-            <a:off x="1051560" y="2743200"/>
-            <a:ext cx="2944368" cy="640080"/>
+            <a:off x="694944" y="2788920"/>
+            <a:ext cx="1735531" cy="685800"/>
           </a:xfrm>
           <a:prstGeom prst="rect">
             <a:avLst/>
@@ -9276,12 +9276,12 @@
           <a:p>
             <a:pPr algn="ctr" indent="0" marL="0">
               <a:lnSpc>
-                <a:spcPct val="100000"/>
+                <a:spcPct val="95000"/>
               </a:lnSpc>
               <a:buNone/>
             </a:pPr>
             <a:r>
-              <a:rPr lang="en-US" sz="1700" b="1" dirty="0">
+              <a:rPr lang="en-US" sz="1350" b="1" dirty="0">
                 <a:solidFill>
                   <a:srgbClr val="3D2352"/>
                 </a:solidFill>
@@ -9289,9 +9289,9 @@
                 <a:ea typeface="Calibri" pitchFamily="34" charset="-122"/>
                 <a:cs typeface="Calibri" pitchFamily="34" charset="-120"/>
               </a:rPr>
-              <a:t>Voice Input</a:t>
-            </a:r>
-            <a:endParaRPr lang="en-US" sz="1700" dirty="0"/>
+              <a:t>Voice input</a:t>
+            </a:r>
+            <a:endParaRPr lang="en-US" sz="1350" dirty="0"/>
           </a:p>
         </p:txBody>
       </p:sp>
@@ -9303,8 +9303,8 @@
         </p:nvSpPr>
         <p:spPr>
           <a:xfrm>
-            <a:off x="1051560" y="3337560"/>
-            <a:ext cx="2944368" cy="365760"/>
+            <a:off x="694944" y="3520440"/>
+            <a:ext cx="1735531" cy="365760"/>
           </a:xfrm>
           <a:prstGeom prst="rect">
             <a:avLst/>
@@ -9320,7 +9320,7 @@
               <a:buNone/>
             </a:pPr>
             <a:r>
-              <a:rPr lang="en-US" sz="1300" dirty="0">
+              <a:rPr lang="en-US" sz="1050" dirty="0">
                 <a:solidFill>
                   <a:srgbClr val="C06A3C"/>
                 </a:solidFill>
@@ -9328,9 +9328,9 @@
                 <a:ea typeface="Calibri" pitchFamily="34" charset="-122"/>
                 <a:cs typeface="Calibri" pitchFamily="34" charset="-120"/>
               </a:rPr>
-              <a:t>(STT)</a:t>
-            </a:r>
-            <a:endParaRPr lang="en-US" sz="1300" dirty="0"/>
+              <a:t>parent speaks</a:t>
+            </a:r>
+            <a:endParaRPr lang="en-US" sz="1050" dirty="0"/>
           </a:p>
         </p:txBody>
       </p:sp>
@@ -9342,7 +9342,7 @@
         </p:nvSpPr>
         <p:spPr>
           <a:xfrm>
-            <a:off x="4201668" y="2880360"/>
+            <a:off x="2467051" y="2994660"/>
             <a:ext cx="457200" cy="457200"/>
           </a:xfrm>
           <a:prstGeom prst="rect">
@@ -9359,7 +9359,7 @@
               <a:buNone/>
             </a:pPr>
             <a:r>
-              <a:rPr lang="en-US" sz="2200" b="1" dirty="0">
+              <a:rPr lang="en-US" sz="1800" b="1" dirty="0">
                 <a:solidFill>
                   <a:srgbClr val="D9824F"/>
                 </a:solidFill>
@@ -9369,7 +9369,7 @@
               </a:rPr>
               <a:t>→</a:t>
             </a:r>
-            <a:endParaRPr lang="en-US" sz="2200" dirty="0"/>
+            <a:endParaRPr lang="en-US" sz="1800" dirty="0"/>
           </a:p>
         </p:txBody>
       </p:sp>
@@ -9381,16 +9381,16 @@
         </p:nvSpPr>
         <p:spPr>
           <a:xfrm>
-            <a:off x="4681728" y="2194560"/>
-            <a:ext cx="3310128" cy="1828800"/>
+            <a:off x="2905963" y="2331720"/>
+            <a:ext cx="1845259" cy="1783080"/>
           </a:xfrm>
           <a:prstGeom prst="roundRect">
             <a:avLst>
-              <a:gd name="adj" fmla="val 5500"/>
+              <a:gd name="adj" fmla="val 5641"/>
             </a:avLst>
           </a:prstGeom>
           <a:solidFill>
-            <a:srgbClr val="FBF6FB"/>
+            <a:srgbClr val="FFFFFF"/>
           </a:solidFill>
           <a:ln/>
           <a:effectLst>
@@ -9410,8 +9410,8 @@
         </p:nvSpPr>
         <p:spPr>
           <a:xfrm>
-            <a:off x="4864608" y="2743200"/>
-            <a:ext cx="2944368" cy="640080"/>
+            <a:off x="2960827" y="2788920"/>
+            <a:ext cx="1735531" cy="685800"/>
           </a:xfrm>
           <a:prstGeom prst="rect">
             <a:avLst/>
@@ -9425,12 +9425,12 @@
           <a:p>
             <a:pPr algn="ctr" indent="0" marL="0">
               <a:lnSpc>
-                <a:spcPct val="100000"/>
+                <a:spcPct val="95000"/>
               </a:lnSpc>
               <a:buNone/>
             </a:pPr>
             <a:r>
-              <a:rPr lang="en-US" sz="1700" b="1" dirty="0">
+              <a:rPr lang="en-US" sz="1350" b="1" dirty="0">
                 <a:solidFill>
                   <a:srgbClr val="3D2352"/>
                 </a:solidFill>
@@ -9438,9 +9438,9 @@
                 <a:ea typeface="Calibri" pitchFamily="34" charset="-122"/>
                 <a:cs typeface="Calibri" pitchFamily="34" charset="-120"/>
               </a:rPr>
-              <a:t>RAG + Fine-Tuned Model</a:t>
-            </a:r>
-            <a:endParaRPr lang="en-US" sz="1700" dirty="0"/>
+              <a:t>STT</a:t>
+            </a:r>
+            <a:endParaRPr lang="en-US" sz="1350" dirty="0"/>
           </a:p>
         </p:txBody>
       </p:sp>
@@ -9452,8 +9452,8 @@
         </p:nvSpPr>
         <p:spPr>
           <a:xfrm>
-            <a:off x="4864608" y="3337560"/>
-            <a:ext cx="2944368" cy="365760"/>
+            <a:off x="2960827" y="3520440"/>
+            <a:ext cx="1735531" cy="365760"/>
           </a:xfrm>
           <a:prstGeom prst="rect">
             <a:avLst/>
@@ -9469,7 +9469,7 @@
               <a:buNone/>
             </a:pPr>
             <a:r>
-              <a:rPr lang="en-US" sz="1300" dirty="0">
+              <a:rPr lang="en-US" sz="1050" dirty="0">
                 <a:solidFill>
                   <a:srgbClr val="C06A3C"/>
                 </a:solidFill>
@@ -9477,9 +9477,9 @@
                 <a:ea typeface="Calibri" pitchFamily="34" charset="-122"/>
                 <a:cs typeface="Calibri" pitchFamily="34" charset="-120"/>
               </a:rPr>
-              <a:t>(Nile-Chat-4B)</a:t>
-            </a:r>
-            <a:endParaRPr lang="en-US" sz="1300" dirty="0"/>
+              <a:t>faster-whisper</a:t>
+            </a:r>
+            <a:endParaRPr lang="en-US" sz="1050" dirty="0"/>
           </a:p>
         </p:txBody>
       </p:sp>
@@ -9491,7 +9491,7 @@
         </p:nvSpPr>
         <p:spPr>
           <a:xfrm>
-            <a:off x="8014716" y="2880360"/>
+            <a:off x="4732934" y="2994660"/>
             <a:ext cx="457200" cy="457200"/>
           </a:xfrm>
           <a:prstGeom prst="rect">
@@ -9508,7 +9508,7 @@
               <a:buNone/>
             </a:pPr>
             <a:r>
-              <a:rPr lang="en-US" sz="2200" b="1" dirty="0">
+              <a:rPr lang="en-US" sz="1800" b="1" dirty="0">
                 <a:solidFill>
                   <a:srgbClr val="D9824F"/>
                 </a:solidFill>
@@ -9518,7 +9518,7 @@
               </a:rPr>
               <a:t>→</a:t>
             </a:r>
-            <a:endParaRPr lang="en-US" sz="2200" dirty="0"/>
+            <a:endParaRPr lang="en-US" sz="1800" dirty="0"/>
           </a:p>
         </p:txBody>
       </p:sp>
@@ -9530,16 +9530,16 @@
         </p:nvSpPr>
         <p:spPr>
           <a:xfrm>
-            <a:off x="8494776" y="2194560"/>
-            <a:ext cx="3310128" cy="1828800"/>
+            <a:off x="5171846" y="2331720"/>
+            <a:ext cx="1845259" cy="1783080"/>
           </a:xfrm>
           <a:prstGeom prst="roundRect">
             <a:avLst>
-              <a:gd name="adj" fmla="val 5500"/>
+              <a:gd name="adj" fmla="val 5641"/>
             </a:avLst>
           </a:prstGeom>
           <a:solidFill>
-            <a:srgbClr val="FFFFFF"/>
+            <a:srgbClr val="FBF6FB"/>
           </a:solidFill>
           <a:ln/>
           <a:effectLst>
@@ -9559,8 +9559,8 @@
         </p:nvSpPr>
         <p:spPr>
           <a:xfrm>
-            <a:off x="8677656" y="2743200"/>
-            <a:ext cx="2944368" cy="640080"/>
+            <a:off x="5226710" y="2788920"/>
+            <a:ext cx="1735531" cy="685800"/>
           </a:xfrm>
           <a:prstGeom prst="rect">
             <a:avLst/>
@@ -9574,12 +9574,12 @@
           <a:p>
             <a:pPr algn="ctr" indent="0" marL="0">
               <a:lnSpc>
-                <a:spcPct val="100000"/>
+                <a:spcPct val="95000"/>
               </a:lnSpc>
               <a:buNone/>
             </a:pPr>
             <a:r>
-              <a:rPr lang="en-US" sz="1700" b="1" dirty="0">
+              <a:rPr lang="en-US" sz="1350" b="1" dirty="0">
                 <a:solidFill>
                   <a:srgbClr val="3D2352"/>
                 </a:solidFill>
@@ -9587,9 +9587,9 @@
                 <a:ea typeface="Calibri" pitchFamily="34" charset="-122"/>
                 <a:cs typeface="Calibri" pitchFamily="34" charset="-120"/>
               </a:rPr>
-              <a:t>Voice Output</a:t>
-            </a:r>
-            <a:endParaRPr lang="en-US" sz="1700" dirty="0"/>
+              <a:t>RAG + Fine-tune</a:t>
+            </a:r>
+            <a:endParaRPr lang="en-US" sz="1350" dirty="0"/>
           </a:p>
         </p:txBody>
       </p:sp>
@@ -9601,8 +9601,8 @@
         </p:nvSpPr>
         <p:spPr>
           <a:xfrm>
-            <a:off x="8677656" y="3337560"/>
-            <a:ext cx="2944368" cy="365760"/>
+            <a:off x="5226710" y="3520440"/>
+            <a:ext cx="1735531" cy="365760"/>
           </a:xfrm>
           <a:prstGeom prst="rect">
             <a:avLst/>
@@ -9618,7 +9618,7 @@
               <a:buNone/>
             </a:pPr>
             <a:r>
-              <a:rPr lang="en-US" sz="1300" dirty="0">
+              <a:rPr lang="en-US" sz="1050" dirty="0">
                 <a:solidFill>
                   <a:srgbClr val="C06A3C"/>
                 </a:solidFill>
@@ -9626,30 +9626,69 @@
                 <a:ea typeface="Calibri" pitchFamily="34" charset="-122"/>
                 <a:cs typeface="Calibri" pitchFamily="34" charset="-120"/>
               </a:rPr>
-              <a:t>(TTS)</a:t>
-            </a:r>
-            <a:endParaRPr lang="en-US" sz="1300" dirty="0"/>
-          </a:p>
-        </p:txBody>
-      </p:sp>
-      <p:sp>
-        <p:nvSpPr>
-          <p:cNvPr id="15" name="Shape 13"/>
+              <a:t>Nile-Chat-4B</a:t>
+            </a:r>
+            <a:endParaRPr lang="en-US" sz="1050" dirty="0"/>
+          </a:p>
+        </p:txBody>
+      </p:sp>
+      <p:sp>
+        <p:nvSpPr>
+          <p:cNvPr id="15" name="Text 13"/>
+          <p:cNvSpPr txBox="1"/>
+          <p:nvPr/>
+        </p:nvSpPr>
+        <p:spPr>
+          <a:xfrm>
+            <a:off x="6998818" y="2994660"/>
+            <a:ext cx="457200" cy="457200"/>
+          </a:xfrm>
+          <a:prstGeom prst="rect">
+            <a:avLst/>
+          </a:prstGeom>
+          <a:noFill/>
+          <a:ln/>
+        </p:spPr>
+        <p:txBody>
+          <a:bodyPr wrap="square" lIns="0" tIns="0" rIns="0" bIns="0" rtlCol="0" anchor="ctr"/>
+          <a:lstStyle/>
+          <a:p>
+            <a:pPr algn="ctr" indent="0" marL="0">
+              <a:buNone/>
+            </a:pPr>
+            <a:r>
+              <a:rPr lang="en-US" sz="1800" b="1" dirty="0">
+                <a:solidFill>
+                  <a:srgbClr val="D9824F"/>
+                </a:solidFill>
+                <a:latin typeface="Calibri" pitchFamily="34" charset="0"/>
+                <a:ea typeface="Calibri" pitchFamily="34" charset="-122"/>
+                <a:cs typeface="Calibri" pitchFamily="34" charset="-120"/>
+              </a:rPr>
+              <a:t>→</a:t>
+            </a:r>
+            <a:endParaRPr lang="en-US" sz="1800" dirty="0"/>
+          </a:p>
+        </p:txBody>
+      </p:sp>
+      <p:sp>
+        <p:nvSpPr>
+          <p:cNvPr id="16" name="Shape 14"/>
           <p:cNvSpPr/>
           <p:nvPr/>
         </p:nvSpPr>
         <p:spPr>
           <a:xfrm>
-            <a:off x="868680" y="4526280"/>
-            <a:ext cx="10451592" cy="1051560"/>
+            <a:off x="7437730" y="2331720"/>
+            <a:ext cx="1845259" cy="1783080"/>
           </a:xfrm>
           <a:prstGeom prst="roundRect">
             <a:avLst>
-              <a:gd name="adj" fmla="val 9565"/>
+              <a:gd name="adj" fmla="val 5641"/>
             </a:avLst>
           </a:prstGeom>
           <a:solidFill>
-            <a:srgbClr val="F7EEE9"/>
+            <a:srgbClr val="FFFFFF"/>
           </a:solidFill>
           <a:ln/>
           <a:effectLst>
@@ -9663,7 +9702,266 @@
       </p:sp>
       <p:sp>
         <p:nvSpPr>
-          <p:cNvPr id="16" name="Text 14"/>
+          <p:cNvPr id="17" name="Text 15"/>
+          <p:cNvSpPr txBox="1"/>
+          <p:nvPr/>
+        </p:nvSpPr>
+        <p:spPr>
+          <a:xfrm>
+            <a:off x="7492594" y="2788920"/>
+            <a:ext cx="1735531" cy="685800"/>
+          </a:xfrm>
+          <a:prstGeom prst="rect">
+            <a:avLst/>
+          </a:prstGeom>
+          <a:noFill/>
+          <a:ln/>
+        </p:spPr>
+        <p:txBody>
+          <a:bodyPr wrap="square" lIns="0" tIns="0" rIns="0" bIns="0" rtlCol="0" anchor="ctr"/>
+          <a:lstStyle/>
+          <a:p>
+            <a:pPr algn="ctr" indent="0" marL="0">
+              <a:lnSpc>
+                <a:spcPct val="95000"/>
+              </a:lnSpc>
+              <a:buNone/>
+            </a:pPr>
+            <a:r>
+              <a:rPr lang="en-US" sz="1350" b="1" dirty="0">
+                <a:solidFill>
+                  <a:srgbClr val="3D2352"/>
+                </a:solidFill>
+                <a:latin typeface="Calibri" pitchFamily="34" charset="0"/>
+                <a:ea typeface="Calibri" pitchFamily="34" charset="-122"/>
+                <a:cs typeface="Calibri" pitchFamily="34" charset="-120"/>
+              </a:rPr>
+              <a:t>TTS</a:t>
+            </a:r>
+            <a:endParaRPr lang="en-US" sz="1350" dirty="0"/>
+          </a:p>
+        </p:txBody>
+      </p:sp>
+      <p:sp>
+        <p:nvSpPr>
+          <p:cNvPr id="18" name="Text 16"/>
+          <p:cNvSpPr txBox="1"/>
+          <p:nvPr/>
+        </p:nvSpPr>
+        <p:spPr>
+          <a:xfrm>
+            <a:off x="7492594" y="3520440"/>
+            <a:ext cx="1735531" cy="365760"/>
+          </a:xfrm>
+          <a:prstGeom prst="rect">
+            <a:avLst/>
+          </a:prstGeom>
+          <a:noFill/>
+          <a:ln/>
+        </p:spPr>
+        <p:txBody>
+          <a:bodyPr wrap="square" lIns="0" tIns="0" rIns="0" bIns="0" rtlCol="0" anchor="ctr"/>
+          <a:lstStyle/>
+          <a:p>
+            <a:pPr algn="ctr" indent="0" marL="0">
+              <a:buNone/>
+            </a:pPr>
+            <a:r>
+              <a:rPr lang="en-US" sz="1050" dirty="0">
+                <a:solidFill>
+                  <a:srgbClr val="C06A3C"/>
+                </a:solidFill>
+                <a:latin typeface="Calibri" pitchFamily="34" charset="0"/>
+                <a:ea typeface="Calibri" pitchFamily="34" charset="-122"/>
+                <a:cs typeface="Calibri" pitchFamily="34" charset="-120"/>
+              </a:rPr>
+              <a:t>Egyptian voice</a:t>
+            </a:r>
+            <a:endParaRPr lang="en-US" sz="1050" dirty="0"/>
+          </a:p>
+        </p:txBody>
+      </p:sp>
+      <p:sp>
+        <p:nvSpPr>
+          <p:cNvPr id="19" name="Text 17"/>
+          <p:cNvSpPr txBox="1"/>
+          <p:nvPr/>
+        </p:nvSpPr>
+        <p:spPr>
+          <a:xfrm>
+            <a:off x="9264701" y="2994660"/>
+            <a:ext cx="457200" cy="457200"/>
+          </a:xfrm>
+          <a:prstGeom prst="rect">
+            <a:avLst/>
+          </a:prstGeom>
+          <a:noFill/>
+          <a:ln/>
+        </p:spPr>
+        <p:txBody>
+          <a:bodyPr wrap="square" lIns="0" tIns="0" rIns="0" bIns="0" rtlCol="0" anchor="ctr"/>
+          <a:lstStyle/>
+          <a:p>
+            <a:pPr algn="ctr" indent="0" marL="0">
+              <a:buNone/>
+            </a:pPr>
+            <a:r>
+              <a:rPr lang="en-US" sz="1800" b="1" dirty="0">
+                <a:solidFill>
+                  <a:srgbClr val="D9824F"/>
+                </a:solidFill>
+                <a:latin typeface="Calibri" pitchFamily="34" charset="0"/>
+                <a:ea typeface="Calibri" pitchFamily="34" charset="-122"/>
+                <a:cs typeface="Calibri" pitchFamily="34" charset="-120"/>
+              </a:rPr>
+              <a:t>→</a:t>
+            </a:r>
+            <a:endParaRPr lang="en-US" sz="1800" dirty="0"/>
+          </a:p>
+        </p:txBody>
+      </p:sp>
+      <p:sp>
+        <p:nvSpPr>
+          <p:cNvPr id="20" name="Shape 18"/>
+          <p:cNvSpPr/>
+          <p:nvPr/>
+        </p:nvSpPr>
+        <p:spPr>
+          <a:xfrm>
+            <a:off x="9703613" y="2331720"/>
+            <a:ext cx="1845259" cy="1783080"/>
+          </a:xfrm>
+          <a:prstGeom prst="roundRect">
+            <a:avLst>
+              <a:gd name="adj" fmla="val 5641"/>
+            </a:avLst>
+          </a:prstGeom>
+          <a:solidFill>
+            <a:srgbClr val="FFFFFF"/>
+          </a:solidFill>
+          <a:ln/>
+          <a:effectLst>
+            <a:outerShdw sx="100000" sy="100000" kx="0" ky="0" algn="bl" rotWithShape="0" blurRad="165100" dist="38100" dir="5400000">
+              <a:srgbClr val="B7A6C9">
+                <a:alpha val="26000"/>
+              </a:srgbClr>
+            </a:outerShdw>
+          </a:effectLst>
+        </p:spPr>
+      </p:sp>
+      <p:sp>
+        <p:nvSpPr>
+          <p:cNvPr id="21" name="Text 19"/>
+          <p:cNvSpPr txBox="1"/>
+          <p:nvPr/>
+        </p:nvSpPr>
+        <p:spPr>
+          <a:xfrm>
+            <a:off x="9758477" y="2788920"/>
+            <a:ext cx="1735531" cy="685800"/>
+          </a:xfrm>
+          <a:prstGeom prst="rect">
+            <a:avLst/>
+          </a:prstGeom>
+          <a:noFill/>
+          <a:ln/>
+        </p:spPr>
+        <p:txBody>
+          <a:bodyPr wrap="square" lIns="0" tIns="0" rIns="0" bIns="0" rtlCol="0" anchor="ctr"/>
+          <a:lstStyle/>
+          <a:p>
+            <a:pPr algn="ctr" indent="0" marL="0">
+              <a:lnSpc>
+                <a:spcPct val="95000"/>
+              </a:lnSpc>
+              <a:buNone/>
+            </a:pPr>
+            <a:r>
+              <a:rPr lang="en-US" sz="1350" b="1" dirty="0">
+                <a:solidFill>
+                  <a:srgbClr val="3D2352"/>
+                </a:solidFill>
+                <a:latin typeface="Calibri" pitchFamily="34" charset="0"/>
+                <a:ea typeface="Calibri" pitchFamily="34" charset="-122"/>
+                <a:cs typeface="Calibri" pitchFamily="34" charset="-120"/>
+              </a:rPr>
+              <a:t>Voice output</a:t>
+            </a:r>
+            <a:endParaRPr lang="en-US" sz="1350" dirty="0"/>
+          </a:p>
+        </p:txBody>
+      </p:sp>
+      <p:sp>
+        <p:nvSpPr>
+          <p:cNvPr id="22" name="Text 20"/>
+          <p:cNvSpPr txBox="1"/>
+          <p:nvPr/>
+        </p:nvSpPr>
+        <p:spPr>
+          <a:xfrm>
+            <a:off x="9758477" y="3520440"/>
+            <a:ext cx="1735531" cy="365760"/>
+          </a:xfrm>
+          <a:prstGeom prst="rect">
+            <a:avLst/>
+          </a:prstGeom>
+          <a:noFill/>
+          <a:ln/>
+        </p:spPr>
+        <p:txBody>
+          <a:bodyPr wrap="square" lIns="0" tIns="0" rIns="0" bIns="0" rtlCol="0" anchor="ctr"/>
+          <a:lstStyle/>
+          <a:p>
+            <a:pPr algn="ctr" indent="0" marL="0">
+              <a:buNone/>
+            </a:pPr>
+            <a:r>
+              <a:rPr lang="en-US" sz="1050" dirty="0">
+                <a:solidFill>
+                  <a:srgbClr val="C06A3C"/>
+                </a:solidFill>
+                <a:latin typeface="Calibri" pitchFamily="34" charset="0"/>
+                <a:ea typeface="Calibri" pitchFamily="34" charset="-122"/>
+                <a:cs typeface="Calibri" pitchFamily="34" charset="-120"/>
+              </a:rPr>
+              <a:t>spoken reply</a:t>
+            </a:r>
+            <a:endParaRPr lang="en-US" sz="1050" dirty="0"/>
+          </a:p>
+        </p:txBody>
+      </p:sp>
+      <p:sp>
+        <p:nvSpPr>
+          <p:cNvPr id="23" name="Shape 21"/>
+          <p:cNvSpPr/>
+          <p:nvPr/>
+        </p:nvSpPr>
+        <p:spPr>
+          <a:xfrm>
+            <a:off x="868680" y="4526280"/>
+            <a:ext cx="10451592" cy="1051560"/>
+          </a:xfrm>
+          <a:prstGeom prst="roundRect">
+            <a:avLst>
+              <a:gd name="adj" fmla="val 9565"/>
+            </a:avLst>
+          </a:prstGeom>
+          <a:solidFill>
+            <a:srgbClr val="F7EEE9"/>
+          </a:solidFill>
+          <a:ln/>
+          <a:effectLst>
+            <a:outerShdw sx="100000" sy="100000" kx="0" ky="0" algn="bl" rotWithShape="0" blurRad="165100" dist="38100" dir="5400000">
+              <a:srgbClr val="B7A6C9">
+                <a:alpha val="26000"/>
+              </a:srgbClr>
+            </a:outerShdw>
+          </a:effectLst>
+        </p:spPr>
+      </p:sp>
+      <p:sp>
+        <p:nvSpPr>
+          <p:cNvPr id="24" name="Text 22"/>
           <p:cNvSpPr txBox="1"/>
           <p:nvPr/>
         </p:nvSpPr>
@@ -9716,7 +10014,7 @@
       </p:sp>
       <p:sp>
         <p:nvSpPr>
-          <p:cNvPr id="17" name="Text 15"/>
+          <p:cNvPr id="25" name="Text 23"/>
           <p:cNvSpPr txBox="1"/>
           <p:nvPr/>
         </p:nvSpPr>
@@ -9755,7 +10053,7 @@
       </p:sp>
       <p:sp>
         <p:nvSpPr>
-          <p:cNvPr id="18" name="Text 16"/>
+          <p:cNvPr id="26" name="Text 24"/>
           <p:cNvSpPr txBox="1"/>
           <p:nvPr/>
         </p:nvSpPr>
@@ -13880,7 +14178,7 @@
         <p:spPr>
           <a:xfrm>
             <a:off x="640080" y="5166360"/>
-            <a:ext cx="6629400" cy="868680"/>
+            <a:ext cx="10908792" cy="868680"/>
           </a:xfrm>
           <a:prstGeom prst="roundRect">
             <a:avLst>
@@ -13908,20 +14206,20 @@
         </p:nvSpPr>
         <p:spPr>
           <a:xfrm>
-            <a:off x="914400" y="5166360"/>
-            <a:ext cx="6309360" cy="868680"/>
-          </a:xfrm>
-          <a:prstGeom prst="rect">
-            <a:avLst/>
-          </a:prstGeom>
-          <a:noFill/>
-          <a:ln/>
-        </p:spPr>
-        <p:txBody>
-          <a:bodyPr wrap="square" lIns="0" tIns="0" rIns="0" bIns="0" rtlCol="0" anchor="ctr"/>
-          <a:lstStyle/>
-          <a:p>
-            <a:pPr indent="0" marL="0">
+            <a:off x="640080" y="5166360"/>
+            <a:ext cx="10908792" cy="868680"/>
+          </a:xfrm>
+          <a:prstGeom prst="rect">
+            <a:avLst/>
+          </a:prstGeom>
+          <a:noFill/>
+          <a:ln/>
+        </p:spPr>
+        <p:txBody>
+          <a:bodyPr wrap="square" lIns="0" tIns="0" rIns="0" bIns="0" rtlCol="0" anchor="ctr"/>
+          <a:lstStyle/>
+          <a:p>
+            <a:pPr algn="ctr" indent="0" marL="0">
               <a:buNone/>
             </a:pPr>
             <a:r>
@@ -13935,7 +14233,7 @@
               </a:rPr>
               <a:t>↩  </a:t>
             </a:r>
-            <a:pPr indent="0" marL="0">
+            <a:pPr algn="ctr" indent="0" marL="0">
               <a:buNone/>
             </a:pPr>
             <a:r>
@@ -13947,9 +14245,9 @@
                 <a:ea typeface="Calibri" pitchFamily="34" charset="-122"/>
                 <a:cs typeface="Calibri" pitchFamily="34" charset="-120"/>
               </a:rPr>
-              <a:t>React frontend displays the response </a:t>
-            </a:r>
-            <a:pPr indent="0" marL="0">
+              <a:t>React frontend displays the grounded response </a:t>
+            </a:r>
+            <a:pPr algn="ctr" indent="0" marL="0">
               <a:buNone/>
             </a:pPr>
             <a:r>
@@ -13961,7 +14259,7 @@
                 <a:ea typeface="Calibri" pitchFamily="34" charset="-122"/>
                 <a:cs typeface="Calibri" pitchFamily="34" charset="-120"/>
               </a:rPr>
-              <a:t>(text)</a:t>
+              <a:t>(text) — with the sources it was built from</a:t>
             </a:r>
             <a:endParaRPr lang="en-US" sz="1500" dirty="0"/>
           </a:p>
@@ -13969,98 +14267,7 @@
       </p:sp>
       <p:sp>
         <p:nvSpPr>
-          <p:cNvPr id="36" name="Shape 34"/>
-          <p:cNvSpPr/>
-          <p:nvPr/>
-        </p:nvSpPr>
-        <p:spPr>
-          <a:xfrm>
-            <a:off x="7406640" y="5166360"/>
-            <a:ext cx="4142232" cy="868680"/>
-          </a:xfrm>
-          <a:prstGeom prst="roundRect">
-            <a:avLst>
-              <a:gd name="adj" fmla="val 11579"/>
-            </a:avLst>
-          </a:prstGeom>
-          <a:solidFill>
-            <a:srgbClr val="FBF6FB"/>
-          </a:solidFill>
-          <a:ln/>
-          <a:effectLst>
-            <a:outerShdw sx="100000" sy="100000" kx="0" ky="0" algn="bl" rotWithShape="0" blurRad="165100" dist="38100" dir="5400000">
-              <a:srgbClr val="B7A6C9">
-                <a:alpha val="26000"/>
-              </a:srgbClr>
-            </a:outerShdw>
-          </a:effectLst>
-        </p:spPr>
-      </p:sp>
-      <p:sp>
-        <p:nvSpPr>
-          <p:cNvPr id="37" name="Text 35"/>
-          <p:cNvSpPr txBox="1"/>
-          <p:nvPr/>
-        </p:nvSpPr>
-        <p:spPr>
-          <a:xfrm>
-            <a:off x="7635240" y="5166360"/>
-            <a:ext cx="3749040" cy="868680"/>
-          </a:xfrm>
-          <a:prstGeom prst="rect">
-            <a:avLst/>
-          </a:prstGeom>
-          <a:noFill/>
-          <a:ln/>
-        </p:spPr>
-        <p:txBody>
-          <a:bodyPr wrap="square" lIns="0" tIns="0" rIns="0" bIns="0" rtlCol="0" anchor="ctr"/>
-          <a:lstStyle/>
-          <a:p>
-            <a:pPr indent="0" marL="0">
-              <a:spcBef>
-                <a:spcPts val="200"/>
-              </a:spcBef>
-              <a:buNone/>
-            </a:pPr>
-            <a:r>
-              <a:rPr lang="en-US" sz="1300" b="1" dirty="0">
-                <a:solidFill>
-                  <a:srgbClr val="3D2352"/>
-                </a:solidFill>
-                <a:latin typeface="Calibri" pitchFamily="34" charset="0"/>
-                <a:ea typeface="Calibri" pitchFamily="34" charset="-122"/>
-                <a:cs typeface="Calibri" pitchFamily="34" charset="-120"/>
-              </a:rPr>
-              <a:t>Conversation history</a:t>
-            </a:r>
-            <a:endParaRPr lang="en-US" sz="1300" dirty="0"/>
-          </a:p>
-          <a:p>
-            <a:pPr indent="0" marL="0">
-              <a:spcBef>
-                <a:spcPts val="200"/>
-              </a:spcBef>
-              <a:buNone/>
-            </a:pPr>
-            <a:r>
-              <a:rPr lang="en-US" sz="1100" dirty="0">
-                <a:solidFill>
-                  <a:srgbClr val="6E6680"/>
-                </a:solidFill>
-                <a:latin typeface="Calibri" pitchFamily="34" charset="0"/>
-                <a:ea typeface="Calibri" pitchFamily="34" charset="-122"/>
-                <a:cs typeface="Calibri" pitchFamily="34" charset="-120"/>
-              </a:rPr>
-              <a:t>stored per session · Postgres / SQLite</a:t>
-            </a:r>
-            <a:endParaRPr lang="en-US" sz="1300" dirty="0"/>
-          </a:p>
-        </p:txBody>
-      </p:sp>
-      <p:sp>
-        <p:nvSpPr>
-          <p:cNvPr id="38" name="Text 36"/>
+          <p:cNvPr id="36" name="Text 34"/>
           <p:cNvSpPr txBox="1"/>
           <p:nvPr/>
         </p:nvSpPr>
@@ -14091,7 +14298,7 @@
                 <a:ea typeface="Calibri" pitchFamily="34" charset="-122"/>
                 <a:cs typeface="Calibri" pitchFamily="34" charset="-120"/>
               </a:rPr>
-              <a:t>Voice/text → React → FastAPI (STT · prompt · RAG · fine-tuned LLM) → response → history.</a:t>
+              <a:t>Voice/text → React → FastAPI (STT · prompt · RAG · fine-tuned LLM) → response.</a:t>
             </a:r>
             <a:endParaRPr lang="en-US" sz="1150" dirty="0"/>
           </a:p>
@@ -14099,7 +14306,7 @@
       </p:sp>
       <p:sp>
         <p:nvSpPr>
-          <p:cNvPr id="39" name="Text 37"/>
+          <p:cNvPr id="37" name="Text 35"/>
           <p:cNvSpPr txBox="1"/>
           <p:nvPr/>
         </p:nvSpPr>

</xml_diff>